<commit_message>
Deployed b852aac with MkDocs version: 1.6.1
</commit_message>
<xml_diff>
--- a/tema6/diapositivas/interaccion.pptx
+++ b/tema6/diapositivas/interaccion.pptx
@@ -4,6 +4,9 @@
   <p:sldMasterIdLst>
     <p:sldMasterId id="2147483648" r:id="rId1"/>
   </p:sldMasterIdLst>
+  <p:notesMasterIdLst>
+    <p:notesMasterId r:id="rId21"/>
+  </p:notesMasterIdLst>
   <p:sldIdLst>
     <p:sldId id="256" r:id="rId2"/>
     <p:sldId id="257" r:id="rId3"/>
@@ -25,9 +28,6 @@
     <p:sldId id="273" r:id="rId19"/>
     <p:sldId id="274" r:id="rId20"/>
   </p:sldIdLst>
-  <p:notesMasterIdLst>
-    <p:notesMasterId r:id="rId21"/>
-  </p:notesMasterIdLst>
   <p:sldSz cx="12192000" cy="6858000"/>
   <p:notesSz cx="6858000" cy="12192000"/>
   <p:defaultTextStyle>
@@ -122,6 +122,11 @@
       </a:defRPr>
     </a:lvl9pPr>
   </p:defaultTextStyle>
+  <p:extLst>
+    <p:ext uri="{EFAFB233-063F-42B5-8137-9DF3F51BA10A}">
+      <p15:sldGuideLst xmlns:p15="http://schemas.microsoft.com/office/powerpoint/2012/main"/>
+    </p:ext>
+  </p:extLst>
 </p:presentation>
 </file>
 
@@ -147,234 +152,10 @@
           <a:chExt cx="0" cy="0"/>
         </a:xfrm>
       </p:grpSpPr>
-      <p:sp>
-        <p:nvSpPr>
-          <p:cNvPr id="2" name="Header Placeholder 1"/>
-          <p:cNvSpPr>
-            <a:spLocks noGrp="1"/>
-          </p:cNvSpPr>
-          <p:nvPr>
-            <p:ph type="hdr" sz="quarter"/>
-          </p:nvPr>
-        </p:nvSpPr>
-        <p:spPr>
-          <a:xfrm>
-            <a:off x="0" y="0"/>
-            <a:ext cx="2971800" cy="458788"/>
-          </a:xfrm>
-          <a:prstGeom prst="rect">
-            <a:avLst/>
-          </a:prstGeom>
-        </p:spPr>
-        <p:txBody>
-          <a:bodyPr vert="horz" lIns="91440" tIns="45720" rIns="91440" bIns="45720" rtlCol="0"/>
-          <a:lstStyle>
-            <a:lvl1pPr algn="l">
-              <a:defRPr sz="1200"/>
-            </a:lvl1pPr>
-          </a:lstStyle>
-          <a:p>
-            <a:endParaRPr lang="en-US"/>
-          </a:p>
-        </p:txBody>
-      </p:sp>
-      <p:sp>
-        <p:nvSpPr>
-          <p:cNvPr id="3" name="Date Placeholder 2"/>
-          <p:cNvSpPr>
-            <a:spLocks noGrp="1"/>
-          </p:cNvSpPr>
-          <p:nvPr>
-            <p:ph type="dt" idx="1"/>
-          </p:nvPr>
-        </p:nvSpPr>
-        <p:spPr>
-          <a:xfrm>
-            <a:off x="3884613" y="0"/>
-            <a:ext cx="2971800" cy="458788"/>
-          </a:xfrm>
-          <a:prstGeom prst="rect">
-            <a:avLst/>
-          </a:prstGeom>
-        </p:spPr>
-        <p:txBody>
-          <a:bodyPr vert="horz" lIns="91440" tIns="45720" rIns="91440" bIns="45720" rtlCol="0"/>
-          <a:lstStyle>
-            <a:lvl1pPr algn="r">
-              <a:defRPr sz="1200"/>
-            </a:lvl1pPr>
-          </a:lstStyle>
-          <a:p>
-            <a:fld id="{5282F153-3F37-0F45-9E97-73ACFA13230C}" type="datetimeFigureOut">
-              <a:rPr lang="en-US"/>
-              <a:t>7/23/19</a:t>
-            </a:fld>
-            <a:endParaRPr lang="en-US"/>
-          </a:p>
-        </p:txBody>
-      </p:sp>
-      <p:sp>
-        <p:nvSpPr>
-          <p:cNvPr id="4" name="Slide Image Placeholder 3"/>
-          <p:cNvSpPr>
-            <a:spLocks noGrp="1" noRot="1" noChangeAspect="1"/>
-          </p:cNvSpPr>
-          <p:nvPr>
-            <p:ph type="sldImg" idx="2"/>
-          </p:nvPr>
-        </p:nvSpPr>
-        <p:spPr>
-          <a:xfrm>
-            <a:off x="685800" y="1143000"/>
-            <a:ext cx="5486400" cy="3086100"/>
-          </a:xfrm>
-          <a:prstGeom prst="rect">
-            <a:avLst/>
-          </a:prstGeom>
-          <a:noFill/>
-          <a:ln w="12700">
-            <a:solidFill>
-              <a:prstClr val="black"/>
-            </a:solidFill>
-          </a:ln>
-        </p:spPr>
-        <p:txBody>
-          <a:bodyPr vert="horz" lIns="91440" tIns="45720" rIns="91440" bIns="45720" rtlCol="0" anchor="ctr"/>
-          <a:lstStyle/>
-          <a:p>
-            <a:endParaRPr lang="en-US"/>
-          </a:p>
-        </p:txBody>
-      </p:sp>
-      <p:sp>
-        <p:nvSpPr>
-          <p:cNvPr id="5" name="Notes Placeholder 4"/>
-          <p:cNvSpPr>
-            <a:spLocks noGrp="1"/>
-          </p:cNvSpPr>
-          <p:nvPr>
-            <p:ph type="body" sz="quarter" idx="3"/>
-          </p:nvPr>
-        </p:nvSpPr>
-        <p:spPr>
-          <a:xfrm>
-            <a:off x="685800" y="4400550"/>
-            <a:ext cx="5486400" cy="3600450"/>
-          </a:xfrm>
-          <a:prstGeom prst="rect">
-            <a:avLst/>
-          </a:prstGeom>
-        </p:spPr>
-        <p:txBody>
-          <a:bodyPr vert="horz" lIns="91440" tIns="45720" rIns="91440" bIns="45720" rtlCol="0"/>
-          <a:lstStyle/>
-          <a:p>
-            <a:pPr lvl="0"/>
-            <a:r>
-              <a:rPr lang="en-US"/>
-              <a:t>Click to edit Master text styles</a:t>
-            </a:r>
-          </a:p>
-          <a:p>
-            <a:pPr lvl="1"/>
-            <a:r>
-              <a:rPr lang="en-US"/>
-              <a:t>Second level</a:t>
-            </a:r>
-          </a:p>
-          <a:p>
-            <a:pPr lvl="2"/>
-            <a:r>
-              <a:rPr lang="en-US"/>
-              <a:t>Third level</a:t>
-            </a:r>
-          </a:p>
-          <a:p>
-            <a:pPr lvl="3"/>
-            <a:r>
-              <a:rPr lang="en-US"/>
-              <a:t>Fourth level</a:t>
-            </a:r>
-          </a:p>
-          <a:p>
-            <a:pPr lvl="4"/>
-            <a:r>
-              <a:rPr lang="en-US"/>
-              <a:t>Fifth level</a:t>
-            </a:r>
-          </a:p>
-        </p:txBody>
-      </p:sp>
-      <p:sp>
-        <p:nvSpPr>
-          <p:cNvPr id="6" name="Footer Placeholder 5"/>
-          <p:cNvSpPr>
-            <a:spLocks noGrp="1"/>
-          </p:cNvSpPr>
-          <p:nvPr>
-            <p:ph type="ftr" sz="quarter" idx="4"/>
-          </p:nvPr>
-        </p:nvSpPr>
-        <p:spPr>
-          <a:xfrm>
-            <a:off x="0" y="8685213"/>
-            <a:ext cx="2971800" cy="458787"/>
-          </a:xfrm>
-          <a:prstGeom prst="rect">
-            <a:avLst/>
-          </a:prstGeom>
-        </p:spPr>
-        <p:txBody>
-          <a:bodyPr vert="horz" lIns="91440" tIns="45720" rIns="91440" bIns="45720" rtlCol="0" anchor="b"/>
-          <a:lstStyle>
-            <a:lvl1pPr algn="l">
-              <a:defRPr sz="1200"/>
-            </a:lvl1pPr>
-          </a:lstStyle>
-          <a:p>
-            <a:endParaRPr lang="en-US"/>
-          </a:p>
-        </p:txBody>
-      </p:sp>
-      <p:sp>
-        <p:nvSpPr>
-          <p:cNvPr id="7" name="Slide Number Placeholder 6"/>
-          <p:cNvSpPr>
-            <a:spLocks noGrp="1"/>
-          </p:cNvSpPr>
-          <p:nvPr>
-            <p:ph type="sldNum" sz="quarter" idx="5"/>
-          </p:nvPr>
-        </p:nvSpPr>
-        <p:spPr>
-          <a:xfrm>
-            <a:off x="3884613" y="8685213"/>
-            <a:ext cx="2971800" cy="458787"/>
-          </a:xfrm>
-          <a:prstGeom prst="rect">
-            <a:avLst/>
-          </a:prstGeom>
-        </p:spPr>
-        <p:txBody>
-          <a:bodyPr vert="horz" lIns="91440" tIns="45720" rIns="91440" bIns="45720" rtlCol="0" anchor="b"/>
-          <a:lstStyle>
-            <a:lvl1pPr algn="r">
-              <a:defRPr sz="1200"/>
-            </a:lvl1pPr>
-          </a:lstStyle>
-          <a:p>
-            <a:fld id="{CE5E9CC1-C706-0F49-92D6-E571CC5EEA8F}" type="slidenum">
-              <a:rPr lang="en-US"/>
-              <a:t>‹#›</a:t>
-            </a:fld>
-            <a:endParaRPr lang="en-US"/>
-          </a:p>
-        </p:txBody>
-      </p:sp>
     </p:spTree>
     <p:extLst>
       <p:ext uri="{BB962C8B-B14F-4D97-AF65-F5344CB8AC3E}">
-        <p14:creationId xmlns:p14="http://schemas.microsoft.com/office/powerpoint/2010/main" val="1024086991"/>
+        <p14:creationId xmlns:p14="http://schemas.microsoft.com/office/powerpoint/2010/main" val="226261671"/>
       </p:ext>
     </p:extLst>
   </p:cSld>
@@ -518,10 +299,6 @@
           <a:bodyPr/>
           <a:lstStyle/>
           <a:p>
-            <a:r>
-              <a:rPr lang="en-US" dirty="0"/>
-              <a:t/>
-            </a:r>
             <a:endParaRPr lang="en-US" dirty="0"/>
           </a:p>
         </p:txBody>
@@ -606,10 +383,6 @@
           <a:bodyPr/>
           <a:lstStyle/>
           <a:p>
-            <a:r>
-              <a:rPr lang="en-US" dirty="0"/>
-              <a:t/>
-            </a:r>
             <a:endParaRPr lang="en-US" dirty="0"/>
           </a:p>
         </p:txBody>
@@ -694,10 +467,6 @@
           <a:bodyPr/>
           <a:lstStyle/>
           <a:p>
-            <a:r>
-              <a:rPr lang="en-US" dirty="0"/>
-              <a:t/>
-            </a:r>
             <a:endParaRPr lang="en-US" dirty="0"/>
           </a:p>
         </p:txBody>
@@ -782,10 +551,6 @@
           <a:bodyPr/>
           <a:lstStyle/>
           <a:p>
-            <a:r>
-              <a:rPr lang="en-US" dirty="0"/>
-              <a:t/>
-            </a:r>
             <a:endParaRPr lang="en-US" dirty="0"/>
           </a:p>
         </p:txBody>
@@ -870,10 +635,6 @@
           <a:bodyPr/>
           <a:lstStyle/>
           <a:p>
-            <a:r>
-              <a:rPr lang="en-US" dirty="0"/>
-              <a:t/>
-            </a:r>
             <a:endParaRPr lang="en-US" dirty="0"/>
           </a:p>
         </p:txBody>
@@ -958,10 +719,6 @@
           <a:bodyPr/>
           <a:lstStyle/>
           <a:p>
-            <a:r>
-              <a:rPr lang="en-US" dirty="0"/>
-              <a:t/>
-            </a:r>
             <a:endParaRPr lang="en-US" dirty="0"/>
           </a:p>
         </p:txBody>
@@ -1046,10 +803,6 @@
           <a:bodyPr/>
           <a:lstStyle/>
           <a:p>
-            <a:r>
-              <a:rPr lang="en-US" dirty="0"/>
-              <a:t/>
-            </a:r>
             <a:endParaRPr lang="en-US" dirty="0"/>
           </a:p>
         </p:txBody>
@@ -1134,10 +887,6 @@
           <a:bodyPr/>
           <a:lstStyle/>
           <a:p>
-            <a:r>
-              <a:rPr lang="en-US" dirty="0"/>
-              <a:t/>
-            </a:r>
             <a:endParaRPr lang="en-US" dirty="0"/>
           </a:p>
         </p:txBody>
@@ -1222,10 +971,6 @@
           <a:bodyPr/>
           <a:lstStyle/>
           <a:p>
-            <a:r>
-              <a:rPr lang="en-US" dirty="0"/>
-              <a:t/>
-            </a:r>
             <a:endParaRPr lang="en-US" dirty="0"/>
           </a:p>
         </p:txBody>
@@ -1310,10 +1055,6 @@
           <a:bodyPr/>
           <a:lstStyle/>
           <a:p>
-            <a:r>
-              <a:rPr lang="en-US" dirty="0"/>
-              <a:t/>
-            </a:r>
             <a:endParaRPr lang="en-US" dirty="0"/>
           </a:p>
         </p:txBody>
@@ -1398,10 +1139,6 @@
           <a:bodyPr/>
           <a:lstStyle/>
           <a:p>
-            <a:r>
-              <a:rPr lang="en-US" dirty="0"/>
-              <a:t/>
-            </a:r>
             <a:endParaRPr lang="en-US" dirty="0"/>
           </a:p>
         </p:txBody>
@@ -1486,10 +1223,6 @@
           <a:bodyPr/>
           <a:lstStyle/>
           <a:p>
-            <a:r>
-              <a:rPr lang="en-US" dirty="0"/>
-              <a:t/>
-            </a:r>
             <a:endParaRPr lang="en-US" dirty="0"/>
           </a:p>
         </p:txBody>
@@ -1574,10 +1307,6 @@
           <a:bodyPr/>
           <a:lstStyle/>
           <a:p>
-            <a:r>
-              <a:rPr lang="en-US" dirty="0"/>
-              <a:t/>
-            </a:r>
             <a:endParaRPr lang="en-US" dirty="0"/>
           </a:p>
         </p:txBody>
@@ -1662,10 +1391,6 @@
           <a:bodyPr/>
           <a:lstStyle/>
           <a:p>
-            <a:r>
-              <a:rPr lang="en-US" dirty="0"/>
-              <a:t/>
-            </a:r>
             <a:endParaRPr lang="en-US" dirty="0"/>
           </a:p>
         </p:txBody>
@@ -1750,10 +1475,6 @@
           <a:bodyPr/>
           <a:lstStyle/>
           <a:p>
-            <a:r>
-              <a:rPr lang="en-US" dirty="0"/>
-              <a:t/>
-            </a:r>
             <a:endParaRPr lang="en-US" dirty="0"/>
           </a:p>
         </p:txBody>
@@ -1838,10 +1559,6 @@
           <a:bodyPr/>
           <a:lstStyle/>
           <a:p>
-            <a:r>
-              <a:rPr lang="en-US" dirty="0"/>
-              <a:t/>
-            </a:r>
             <a:endParaRPr lang="en-US" dirty="0"/>
           </a:p>
         </p:txBody>
@@ -1926,10 +1643,6 @@
           <a:bodyPr/>
           <a:lstStyle/>
           <a:p>
-            <a:r>
-              <a:rPr lang="en-US" dirty="0"/>
-              <a:t/>
-            </a:r>
             <a:endParaRPr lang="en-US" dirty="0"/>
           </a:p>
         </p:txBody>
@@ -2014,10 +1727,6 @@
           <a:bodyPr/>
           <a:lstStyle/>
           <a:p>
-            <a:r>
-              <a:rPr lang="en-US" dirty="0"/>
-              <a:t/>
-            </a:r>
             <a:endParaRPr lang="en-US" dirty="0"/>
           </a:p>
         </p:txBody>
@@ -2102,10 +1811,6 @@
           <a:bodyPr/>
           <a:lstStyle/>
           <a:p>
-            <a:r>
-              <a:rPr lang="en-US" dirty="0"/>
-              <a:t/>
-            </a:r>
             <a:endParaRPr lang="en-US" dirty="0"/>
           </a:p>
         </p:txBody>
@@ -2179,6 +1884,11 @@
 <file path=ppt/slideMasters/slideMaster1.xml><?xml version="1.0" encoding="utf-8"?>
 <p:sldMaster xmlns:a="http://schemas.openxmlformats.org/drawingml/2006/main" xmlns:r="http://schemas.openxmlformats.org/officeDocument/2006/relationships" xmlns:p="http://schemas.openxmlformats.org/presentationml/2006/main">
   <p:cSld>
+    <p:bg>
+      <p:bgRef idx="1001">
+        <a:schemeClr val="bg1"/>
+      </p:bgRef>
+    </p:bg>
     <p:spTree>
       <p:nvGrpSpPr>
         <p:cNvPr id="1" name=""/>
@@ -2461,6 +2171,7 @@
         <a:solidFill>
           <a:srgbClr val="303F9F"/>
         </a:solidFill>
+        <a:effectLst/>
       </p:bgPr>
     </p:bg>
     <p:spTree>
@@ -2498,7 +2209,7 @@
           <a:bodyPr wrap="square" rtlCol="0" anchor="ctr"/>
           <a:lstStyle/>
           <a:p>
-            <a:pPr indent="0" marL="0">
+            <a:pPr marL="0" indent="0">
               <a:buNone/>
             </a:pPr>
             <a:r>
@@ -2537,7 +2248,7 @@
           <a:bodyPr wrap="square" rtlCol="0" anchor="ctr"/>
           <a:lstStyle/>
           <a:p>
-            <a:pPr algn="l" indent="0" marL="0">
+            <a:pPr marL="0" indent="0" algn="l">
               <a:buNone/>
             </a:pPr>
             <a:r>
@@ -2579,6 +2290,13 @@
             <a:prstDash val="solid"/>
           </a:ln>
         </p:spPr>
+        <p:txBody>
+          <a:bodyPr/>
+          <a:lstStyle/>
+          <a:p>
+            <a:endParaRPr lang="es-ES"/>
+          </a:p>
+        </p:txBody>
       </p:sp>
       <p:sp>
         <p:nvSpPr>
@@ -2601,7 +2319,7 @@
           <a:bodyPr wrap="square" rtlCol="0" anchor="ctr"/>
           <a:lstStyle/>
           <a:p>
-            <a:pPr indent="0" marL="0">
+            <a:pPr marL="0" indent="0">
               <a:buNone/>
             </a:pPr>
             <a:r>
@@ -2668,6 +2386,13 @@
             <a:prstDash val="solid"/>
           </a:ln>
         </p:spPr>
+        <p:txBody>
+          <a:bodyPr/>
+          <a:lstStyle/>
+          <a:p>
+            <a:endParaRPr lang="es-ES"/>
+          </a:p>
+        </p:txBody>
       </p:sp>
       <p:sp>
         <p:nvSpPr>
@@ -2690,7 +2415,7 @@
           <a:bodyPr wrap="square" rtlCol="0" anchor="ctr"/>
           <a:lstStyle/>
           <a:p>
-            <a:pPr indent="0" marL="0">
+            <a:pPr marL="0" indent="0">
               <a:buNone/>
             </a:pPr>
             <a:r>
@@ -2729,7 +2454,7 @@
           <a:bodyPr wrap="square" rtlCol="0" anchor="t"/>
           <a:lstStyle/>
           <a:p>
-            <a:pPr indent="0" marL="0">
+            <a:pPr marL="0" indent="0">
               <a:spcAft>
                 <a:spcPts val="800"/>
               </a:spcAft>
@@ -2749,7 +2474,7 @@
             <a:endParaRPr lang="en-US" sz="1600" dirty="0"/>
           </a:p>
           <a:p>
-            <a:pPr indent="0" marL="0">
+            <a:pPr marL="0" indent="0">
               <a:spcAft>
                 <a:spcPts val="800"/>
               </a:spcAft>
@@ -2791,17 +2516,24 @@
             <a:prstDash val="solid"/>
           </a:ln>
         </p:spPr>
+        <p:txBody>
+          <a:bodyPr/>
+          <a:lstStyle/>
+          <a:p>
+            <a:endParaRPr lang="es-ES"/>
+          </a:p>
+        </p:txBody>
       </p:sp>
       <p:pic>
         <p:nvPicPr>
-          <p:cNvPr id="6" name="Image 0" descr="C:/Users/Aitor/Documents/apuntes-profe/entornos-de-desarrollo/docs/tema6/img/dia-lifeline-destruccion.png">    </p:cNvPr>
+          <p:cNvPr id="6" name="Image 0" descr="C:/Users/Aitor/Documents/apuntes-profe/entornos-de-desarrollo/docs/tema6/img/dia-lifeline-destruccion.png"/>
           <p:cNvPicPr>
             <a:picLocks noChangeAspect="1"/>
           </p:cNvPicPr>
           <p:nvPr/>
         </p:nvPicPr>
         <p:blipFill>
-          <a:blip r:embed="rId1"/>
+          <a:blip r:embed="rId3"/>
           <a:stretch>
             <a:fillRect/>
           </a:stretch>
@@ -2837,7 +2569,7 @@
           <a:bodyPr wrap="square" rtlCol="0" anchor="t"/>
           <a:lstStyle/>
           <a:p>
-            <a:pPr algn="ctr" indent="0" marL="0">
+            <a:pPr marL="0" indent="0" algn="ctr">
               <a:buNone/>
             </a:pPr>
             <a:r>
@@ -2876,17 +2608,24 @@
             <a:prstDash val="solid"/>
           </a:ln>
         </p:spPr>
+        <p:txBody>
+          <a:bodyPr/>
+          <a:lstStyle/>
+          <a:p>
+            <a:endParaRPr lang="es-ES"/>
+          </a:p>
+        </p:txBody>
       </p:sp>
       <p:pic>
         <p:nvPicPr>
-          <p:cNvPr id="9" name="Image 1" descr="C:/Users/Aitor/Documents/apuntes-profe/entornos-de-desarrollo/docs/tema6/img/dia-mensaje-destruir.png">    </p:cNvPr>
+          <p:cNvPr id="9" name="Image 1" descr="C:/Users/Aitor/Documents/apuntes-profe/entornos-de-desarrollo/docs/tema6/img/dia-mensaje-destruir.png"/>
           <p:cNvPicPr>
             <a:picLocks noChangeAspect="1"/>
           </p:cNvPicPr>
           <p:nvPr/>
         </p:nvPicPr>
         <p:blipFill>
-          <a:blip r:embed="rId2"/>
+          <a:blip r:embed="rId4"/>
           <a:stretch>
             <a:fillRect/>
           </a:stretch>
@@ -2922,7 +2661,7 @@
           <a:bodyPr wrap="square" rtlCol="0" anchor="t"/>
           <a:lstStyle/>
           <a:p>
-            <a:pPr algn="ctr" indent="0" marL="0">
+            <a:pPr marL="0" indent="0" algn="ctr">
               <a:buNone/>
             </a:pPr>
             <a:r>
@@ -2961,7 +2700,7 @@
           <a:bodyPr wrap="square" rtlCol="0" anchor="ctr"/>
           <a:lstStyle/>
           <a:p>
-            <a:pPr algn="r" indent="0" marL="0">
+            <a:pPr marL="0" indent="0" algn="r">
               <a:buNone/>
             </a:pPr>
             <a:r>
@@ -3028,6 +2767,13 @@
             <a:prstDash val="solid"/>
           </a:ln>
         </p:spPr>
+        <p:txBody>
+          <a:bodyPr/>
+          <a:lstStyle/>
+          <a:p>
+            <a:endParaRPr lang="es-ES"/>
+          </a:p>
+        </p:txBody>
       </p:sp>
       <p:sp>
         <p:nvSpPr>
@@ -3050,7 +2796,7 @@
           <a:bodyPr wrap="square" rtlCol="0" anchor="ctr"/>
           <a:lstStyle/>
           <a:p>
-            <a:pPr indent="0" marL="0">
+            <a:pPr marL="0" indent="0">
               <a:buNone/>
             </a:pPr>
             <a:r>
@@ -3089,17 +2835,24 @@
             <a:prstDash val="solid"/>
           </a:ln>
         </p:spPr>
+        <p:txBody>
+          <a:bodyPr/>
+          <a:lstStyle/>
+          <a:p>
+            <a:endParaRPr lang="es-ES"/>
+          </a:p>
+        </p:txBody>
       </p:sp>
       <p:pic>
         <p:nvPicPr>
-          <p:cNvPr id="5" name="Image 0" descr="C:/Users/Aitor/Documents/apuntes-profe/entornos-de-desarrollo/docs/tema6/img/secuencia-tipos-resumen.png">    </p:cNvPr>
+          <p:cNvPr id="5" name="Image 0" descr="C:/Users/Aitor/Documents/apuntes-profe/entornos-de-desarrollo/docs/tema6/img/secuencia-tipos-resumen.png"/>
           <p:cNvPicPr>
             <a:picLocks noChangeAspect="1"/>
           </p:cNvPicPr>
           <p:nvPr/>
         </p:nvPicPr>
         <p:blipFill>
-          <a:blip r:embed="rId1"/>
+          <a:blip r:embed="rId3"/>
           <a:stretch>
             <a:fillRect/>
           </a:stretch>
@@ -3135,7 +2888,7 @@
           <a:bodyPr wrap="square" rtlCol="0" anchor="t"/>
           <a:lstStyle/>
           <a:p>
-            <a:pPr algn="ctr" indent="0" marL="0">
+            <a:pPr marL="0" indent="0" algn="ctr">
               <a:buNone/>
             </a:pPr>
             <a:r>
@@ -3174,7 +2927,7 @@
           <a:bodyPr wrap="square" rtlCol="0" anchor="ctr"/>
           <a:lstStyle/>
           <a:p>
-            <a:pPr algn="r" indent="0" marL="0">
+            <a:pPr marL="0" indent="0" algn="r">
               <a:buNone/>
             </a:pPr>
             <a:r>
@@ -3241,6 +2994,13 @@
             <a:prstDash val="solid"/>
           </a:ln>
         </p:spPr>
+        <p:txBody>
+          <a:bodyPr/>
+          <a:lstStyle/>
+          <a:p>
+            <a:endParaRPr lang="es-ES"/>
+          </a:p>
+        </p:txBody>
       </p:sp>
       <p:sp>
         <p:nvSpPr>
@@ -3263,7 +3023,7 @@
           <a:bodyPr wrap="square" rtlCol="0" anchor="ctr"/>
           <a:lstStyle/>
           <a:p>
-            <a:pPr indent="0" marL="0">
+            <a:pPr marL="0" indent="0">
               <a:buNone/>
             </a:pPr>
             <a:r>
@@ -3283,14 +3043,14 @@
       </p:sp>
       <p:pic>
         <p:nvPicPr>
-          <p:cNvPr id="4" name="Image 0" descr="C:/Users/Aitor/Documents/apuntes-profe/entornos-de-desarrollo/docs/tema6/img/secuencia-llamada-completo.png">    </p:cNvPr>
+          <p:cNvPr id="4" name="Image 0" descr="C:/Users/Aitor/Documents/apuntes-profe/entornos-de-desarrollo/docs/tema6/img/secuencia-llamada-completo.png"/>
           <p:cNvPicPr>
             <a:picLocks noChangeAspect="1"/>
           </p:cNvPicPr>
           <p:nvPr/>
         </p:nvPicPr>
         <p:blipFill>
-          <a:blip r:embed="rId1"/>
+          <a:blip r:embed="rId3"/>
           <a:stretch>
             <a:fillRect/>
           </a:stretch>
@@ -3326,7 +3086,7 @@
           <a:bodyPr wrap="square" rtlCol="0" anchor="t"/>
           <a:lstStyle/>
           <a:p>
-            <a:pPr indent="0" marL="0">
+            <a:pPr marL="0" indent="0">
               <a:spcAft>
                 <a:spcPts val="800"/>
               </a:spcAft>
@@ -3346,7 +3106,7 @@
             <a:endParaRPr lang="en-US" sz="1300" dirty="0"/>
           </a:p>
           <a:p>
-            <a:pPr indent="0" marL="0">
+            <a:pPr marL="0" indent="0">
               <a:spcAft>
                 <a:spcPts val="800"/>
               </a:spcAft>
@@ -3366,7 +3126,7 @@
             <a:endParaRPr lang="en-US" sz="1300" dirty="0"/>
           </a:p>
           <a:p>
-            <a:pPr indent="0" marL="0">
+            <a:pPr marL="0" indent="0">
               <a:spcAft>
                 <a:spcPts val="800"/>
               </a:spcAft>
@@ -3386,7 +3146,7 @@
             <a:endParaRPr lang="en-US" sz="1300" dirty="0"/>
           </a:p>
           <a:p>
-            <a:pPr indent="0" marL="0">
+            <a:pPr marL="0" indent="0">
               <a:spcAft>
                 <a:spcPts val="800"/>
               </a:spcAft>
@@ -3406,7 +3166,7 @@
             <a:endParaRPr lang="en-US" sz="1300" dirty="0"/>
           </a:p>
           <a:p>
-            <a:pPr indent="0" marL="0">
+            <a:pPr marL="0" indent="0">
               <a:spcAft>
                 <a:spcPts val="800"/>
               </a:spcAft>
@@ -3426,7 +3186,7 @@
             <a:endParaRPr lang="en-US" sz="1300" dirty="0"/>
           </a:p>
           <a:p>
-            <a:pPr indent="0" marL="0">
+            <a:pPr marL="0" indent="0">
               <a:spcAft>
                 <a:spcPts val="800"/>
               </a:spcAft>
@@ -3446,7 +3206,7 @@
             <a:endParaRPr lang="en-US" sz="1300" dirty="0"/>
           </a:p>
           <a:p>
-            <a:pPr indent="0" marL="0">
+            <a:pPr marL="0" indent="0">
               <a:spcAft>
                 <a:spcPts val="800"/>
               </a:spcAft>
@@ -3491,6 +3251,13 @@
             <a:prstDash val="solid"/>
           </a:ln>
         </p:spPr>
+        <p:txBody>
+          <a:bodyPr/>
+          <a:lstStyle/>
+          <a:p>
+            <a:endParaRPr lang="es-ES"/>
+          </a:p>
+        </p:txBody>
       </p:sp>
       <p:sp>
         <p:nvSpPr>
@@ -3513,7 +3280,7 @@
           <a:bodyPr wrap="square" rtlCol="0" anchor="ctr"/>
           <a:lstStyle/>
           <a:p>
-            <a:pPr indent="0" marL="0">
+            <a:pPr marL="0" indent="0">
               <a:buNone/>
             </a:pPr>
             <a:r>
@@ -3552,7 +3319,7 @@
           <a:bodyPr wrap="square" rtlCol="0" anchor="ctr"/>
           <a:lstStyle/>
           <a:p>
-            <a:pPr algn="r" indent="0" marL="0">
+            <a:pPr marL="0" indent="0" algn="r">
               <a:buNone/>
             </a:pPr>
             <a:r>
@@ -3619,6 +3386,13 @@
             <a:prstDash val="solid"/>
           </a:ln>
         </p:spPr>
+        <p:txBody>
+          <a:bodyPr/>
+          <a:lstStyle/>
+          <a:p>
+            <a:endParaRPr lang="es-ES"/>
+          </a:p>
+        </p:txBody>
       </p:sp>
       <p:sp>
         <p:nvSpPr>
@@ -3641,7 +3415,7 @@
           <a:bodyPr wrap="square" rtlCol="0" anchor="ctr"/>
           <a:lstStyle/>
           <a:p>
-            <a:pPr indent="0" marL="0">
+            <a:pPr marL="0" indent="0">
               <a:buNone/>
             </a:pPr>
             <a:r>
@@ -3680,17 +3454,24 @@
             <a:prstDash val="solid"/>
           </a:ln>
         </p:spPr>
+        <p:txBody>
+          <a:bodyPr/>
+          <a:lstStyle/>
+          <a:p>
+            <a:endParaRPr lang="es-ES"/>
+          </a:p>
+        </p:txBody>
       </p:sp>
       <p:pic>
         <p:nvPicPr>
-          <p:cNvPr id="5" name="Image 0" descr="C:/Users/Aitor/Documents/apuntes-profe/entornos-de-desarrollo/docs/tema6/img/secuencia-lavadora-completo.png">    </p:cNvPr>
+          <p:cNvPr id="5" name="Image 0" descr="C:/Users/Aitor/Documents/apuntes-profe/entornos-de-desarrollo/docs/tema6/img/secuencia-lavadora-completo.png"/>
           <p:cNvPicPr>
             <a:picLocks noChangeAspect="1"/>
           </p:cNvPicPr>
           <p:nvPr/>
         </p:nvPicPr>
         <p:blipFill>
-          <a:blip r:embed="rId1"/>
+          <a:blip r:embed="rId3"/>
           <a:stretch>
             <a:fillRect/>
           </a:stretch>
@@ -3726,7 +3507,7 @@
           <a:bodyPr wrap="square" rtlCol="0" anchor="t"/>
           <a:lstStyle/>
           <a:p>
-            <a:pPr algn="ctr" indent="0" marL="0">
+            <a:pPr marL="0" indent="0" algn="ctr">
               <a:buNone/>
             </a:pPr>
             <a:r>
@@ -3765,7 +3546,7 @@
           <a:bodyPr wrap="square" rtlCol="0" anchor="ctr"/>
           <a:lstStyle/>
           <a:p>
-            <a:pPr algn="r" indent="0" marL="0">
+            <a:pPr marL="0" indent="0" algn="r">
               <a:buNone/>
             </a:pPr>
             <a:r>
@@ -3832,6 +3613,13 @@
             <a:prstDash val="solid"/>
           </a:ln>
         </p:spPr>
+        <p:txBody>
+          <a:bodyPr/>
+          <a:lstStyle/>
+          <a:p>
+            <a:endParaRPr lang="es-ES"/>
+          </a:p>
+        </p:txBody>
       </p:sp>
       <p:sp>
         <p:nvSpPr>
@@ -3854,7 +3642,7 @@
           <a:bodyPr wrap="square" rtlCol="0" anchor="ctr"/>
           <a:lstStyle/>
           <a:p>
-            <a:pPr indent="0" marL="0">
+            <a:pPr marL="0" indent="0">
               <a:buNone/>
             </a:pPr>
             <a:r>
@@ -3893,7 +3681,7 @@
           <a:bodyPr wrap="square" rtlCol="0" anchor="t"/>
           <a:lstStyle/>
           <a:p>
-            <a:pPr indent="0" marL="0">
+            <a:pPr marL="0" indent="0">
               <a:spcAft>
                 <a:spcPts val="800"/>
               </a:spcAft>
@@ -3913,7 +3701,7 @@
             <a:endParaRPr lang="en-US" sz="1700" dirty="0"/>
           </a:p>
           <a:p>
-            <a:pPr indent="0" marL="0">
+            <a:pPr marL="0" indent="0">
               <a:spcAft>
                 <a:spcPts val="800"/>
               </a:spcAft>
@@ -3958,6 +3746,13 @@
             <a:prstDash val="solid"/>
           </a:ln>
         </p:spPr>
+        <p:txBody>
+          <a:bodyPr/>
+          <a:lstStyle/>
+          <a:p>
+            <a:endParaRPr lang="es-ES"/>
+          </a:p>
+        </p:txBody>
       </p:sp>
       <p:sp>
         <p:nvSpPr>
@@ -3980,7 +3775,7 @@
           <a:bodyPr wrap="square" rtlCol="0" anchor="ctr"/>
           <a:lstStyle/>
           <a:p>
-            <a:pPr indent="0" marL="0">
+            <a:pPr marL="0" indent="0">
               <a:buNone/>
             </a:pPr>
             <a:r>
@@ -4014,15 +3809,27 @@
         </p:nvGraphicFramePr>
         <p:xfrm>
           <a:off x="548640" y="3794760"/>
-          <a:ext cx="11091672" cy="914400"/>
+          <a:ext cx="11091672" cy="2743200"/>
         </p:xfrm>
         <a:graphic>
           <a:graphicData uri="http://schemas.openxmlformats.org/drawingml/2006/table">
             <a:tbl>
               <a:tblPr/>
               <a:tblGrid>
-                <a:gridCol w="3105668"/>
-                <a:gridCol w="7986004"/>
+                <a:gridCol w="3105668">
+                  <a:extLst>
+                    <a:ext uri="{9D8B030D-6E8A-4147-A177-3AD203B41FA5}">
+                      <a16:colId xmlns:a16="http://schemas.microsoft.com/office/drawing/2014/main" val="20000"/>
+                    </a:ext>
+                  </a:extLst>
+                </a:gridCol>
+                <a:gridCol w="7986004">
+                  <a:extLst>
+                    <a:ext uri="{9D8B030D-6E8A-4147-A177-3AD203B41FA5}">
+                      <a16:colId xmlns:a16="http://schemas.microsoft.com/office/drawing/2014/main" val="20001"/>
+                    </a:ext>
+                  </a:extLst>
+                </a:gridCol>
               </a:tblGrid>
               <a:tr h="685800">
                 <a:tc>
@@ -4030,7 +3837,7 @@
                     <a:bodyPr/>
                     <a:lstStyle/>
                     <a:p>
-                      <a:pPr algn="ctr" indent="0" marL="0">
+                      <a:pPr marL="0" indent="0" algn="ctr">
                         <a:buNone/>
                       </a:pPr>
                       <a:r>
@@ -4098,7 +3905,7 @@
                     <a:bodyPr/>
                     <a:lstStyle/>
                     <a:p>
-                      <a:pPr algn="ctr" indent="0" marL="0">
+                      <a:pPr marL="0" indent="0" algn="ctr">
                         <a:buNone/>
                       </a:pPr>
                       <a:r>
@@ -4161,6 +3968,11 @@
                     </a:solidFill>
                   </a:tcPr>
                 </a:tc>
+                <a:extLst>
+                  <a:ext uri="{0D108BD9-81ED-4DB2-BD59-A6C34878D82A}">
+                    <a16:rowId xmlns:a16="http://schemas.microsoft.com/office/drawing/2014/main" val="10000"/>
+                  </a:ext>
+                </a:extLst>
               </a:tr>
               <a:tr h="685800">
                 <a:tc>
@@ -4168,7 +3980,7 @@
                     <a:bodyPr/>
                     <a:lstStyle/>
                     <a:p>
-                      <a:pPr algn="l" indent="0" marL="0">
+                      <a:pPr marL="0" indent="0" algn="l">
                         <a:buNone/>
                       </a:pPr>
                       <a:r>
@@ -4236,7 +4048,7 @@
                     <a:bodyPr/>
                     <a:lstStyle/>
                     <a:p>
-                      <a:pPr algn="l" indent="0" marL="0">
+                      <a:pPr marL="0" indent="0" algn="l">
                         <a:buNone/>
                       </a:pPr>
                       <a:r>
@@ -4299,6 +4111,11 @@
                     </a:solidFill>
                   </a:tcPr>
                 </a:tc>
+                <a:extLst>
+                  <a:ext uri="{0D108BD9-81ED-4DB2-BD59-A6C34878D82A}">
+                    <a16:rowId xmlns:a16="http://schemas.microsoft.com/office/drawing/2014/main" val="10001"/>
+                  </a:ext>
+                </a:extLst>
               </a:tr>
               <a:tr h="685800">
                 <a:tc>
@@ -4306,7 +4123,7 @@
                     <a:bodyPr/>
                     <a:lstStyle/>
                     <a:p>
-                      <a:pPr algn="l" indent="0" marL="0">
+                      <a:pPr marL="0" indent="0" algn="l">
                         <a:buNone/>
                       </a:pPr>
                       <a:r>
@@ -4374,7 +4191,7 @@
                     <a:bodyPr/>
                     <a:lstStyle/>
                     <a:p>
-                      <a:pPr algn="l" indent="0" marL="0">
+                      <a:pPr marL="0" indent="0" algn="l">
                         <a:buNone/>
                       </a:pPr>
                       <a:r>
@@ -4437,6 +4254,11 @@
                     </a:solidFill>
                   </a:tcPr>
                 </a:tc>
+                <a:extLst>
+                  <a:ext uri="{0D108BD9-81ED-4DB2-BD59-A6C34878D82A}">
+                    <a16:rowId xmlns:a16="http://schemas.microsoft.com/office/drawing/2014/main" val="10002"/>
+                  </a:ext>
+                </a:extLst>
               </a:tr>
               <a:tr h="685800">
                 <a:tc>
@@ -4444,7 +4266,7 @@
                     <a:bodyPr/>
                     <a:lstStyle/>
                     <a:p>
-                      <a:pPr algn="l" indent="0" marL="0">
+                      <a:pPr marL="0" indent="0" algn="l">
                         <a:buNone/>
                       </a:pPr>
                       <a:r>
@@ -4512,7 +4334,7 @@
                     <a:bodyPr/>
                     <a:lstStyle/>
                     <a:p>
-                      <a:pPr algn="l" indent="0" marL="0">
+                      <a:pPr marL="0" indent="0" algn="l">
                         <a:buNone/>
                       </a:pPr>
                       <a:r>
@@ -4575,6 +4397,11 @@
                     </a:solidFill>
                   </a:tcPr>
                 </a:tc>
+                <a:extLst>
+                  <a:ext uri="{0D108BD9-81ED-4DB2-BD59-A6C34878D82A}">
+                    <a16:rowId xmlns:a16="http://schemas.microsoft.com/office/drawing/2014/main" val="10003"/>
+                  </a:ext>
+                </a:extLst>
               </a:tr>
             </a:tbl>
           </a:graphicData>
@@ -4601,7 +4428,7 @@
           <a:bodyPr wrap="square" rtlCol="0" anchor="ctr"/>
           <a:lstStyle/>
           <a:p>
-            <a:pPr algn="r" indent="0" marL="0">
+            <a:pPr marL="0" indent="0" algn="r">
               <a:buNone/>
             </a:pPr>
             <a:r>
@@ -4668,6 +4495,13 @@
             <a:prstDash val="solid"/>
           </a:ln>
         </p:spPr>
+        <p:txBody>
+          <a:bodyPr/>
+          <a:lstStyle/>
+          <a:p>
+            <a:endParaRPr lang="es-ES"/>
+          </a:p>
+        </p:txBody>
       </p:sp>
       <p:sp>
         <p:nvSpPr>
@@ -4690,7 +4524,7 @@
           <a:bodyPr wrap="square" rtlCol="0" anchor="ctr"/>
           <a:lstStyle/>
           <a:p>
-            <a:pPr indent="0" marL="0">
+            <a:pPr marL="0" indent="0">
               <a:buNone/>
             </a:pPr>
             <a:r>
@@ -4729,7 +4563,7 @@
           <a:bodyPr wrap="square" rtlCol="0" anchor="t"/>
           <a:lstStyle/>
           <a:p>
-            <a:pPr indent="0" marL="0">
+            <a:pPr marL="0" indent="0">
               <a:spcAft>
                 <a:spcPts val="800"/>
               </a:spcAft>
@@ -4749,7 +4583,7 @@
             <a:endParaRPr lang="en-US" sz="1500" dirty="0"/>
           </a:p>
           <a:p>
-            <a:pPr indent="0" marL="0">
+            <a:pPr marL="0" indent="0">
               <a:spcAft>
                 <a:spcPts val="800"/>
               </a:spcAft>
@@ -4769,7 +4603,7 @@
             <a:endParaRPr lang="en-US" sz="1500" dirty="0"/>
           </a:p>
           <a:p>
-            <a:pPr indent="0" marL="0">
+            <a:pPr marL="0" indent="0">
               <a:spcAft>
                 <a:spcPts val="800"/>
               </a:spcAft>
@@ -4814,6 +4648,13 @@
             <a:prstDash val="solid"/>
           </a:ln>
         </p:spPr>
+        <p:txBody>
+          <a:bodyPr/>
+          <a:lstStyle/>
+          <a:p>
+            <a:endParaRPr lang="es-ES"/>
+          </a:p>
+        </p:txBody>
       </p:sp>
       <p:sp>
         <p:nvSpPr>
@@ -4836,7 +4677,7 @@
           <a:bodyPr wrap="square" rtlCol="0" anchor="ctr"/>
           <a:lstStyle/>
           <a:p>
-            <a:pPr algn="ctr" indent="0" marL="0">
+            <a:pPr marL="0" indent="0" algn="ctr">
               <a:buNone/>
             </a:pPr>
             <a:r>
@@ -4878,6 +4719,13 @@
             <a:prstDash val="solid"/>
           </a:ln>
         </p:spPr>
+        <p:txBody>
+          <a:bodyPr/>
+          <a:lstStyle/>
+          <a:p>
+            <a:endParaRPr lang="es-ES"/>
+          </a:p>
+        </p:txBody>
       </p:sp>
       <p:sp>
         <p:nvSpPr>
@@ -4900,7 +4748,7 @@
           <a:bodyPr wrap="square" rtlCol="0" anchor="ctr"/>
           <a:lstStyle/>
           <a:p>
-            <a:pPr algn="ctr" indent="0" marL="0">
+            <a:pPr marL="0" indent="0" algn="ctr">
               <a:buNone/>
             </a:pPr>
             <a:r>
@@ -4942,6 +4790,13 @@
             <a:prstDash val="solid"/>
           </a:ln>
         </p:spPr>
+        <p:txBody>
+          <a:bodyPr/>
+          <a:lstStyle/>
+          <a:p>
+            <a:endParaRPr lang="es-ES"/>
+          </a:p>
+        </p:txBody>
       </p:sp>
       <p:sp>
         <p:nvSpPr>
@@ -4964,7 +4819,7 @@
           <a:bodyPr wrap="square" rtlCol="0" anchor="ctr"/>
           <a:lstStyle/>
           <a:p>
-            <a:pPr algn="ctr" indent="0" marL="0">
+            <a:pPr marL="0" indent="0" algn="ctr">
               <a:buNone/>
             </a:pPr>
             <a:r>
@@ -5006,6 +4861,13 @@
             <a:prstDash val="solid"/>
           </a:ln>
         </p:spPr>
+        <p:txBody>
+          <a:bodyPr/>
+          <a:lstStyle/>
+          <a:p>
+            <a:endParaRPr lang="es-ES"/>
+          </a:p>
+        </p:txBody>
       </p:sp>
       <p:sp>
         <p:nvSpPr>
@@ -5028,7 +4890,7 @@
           <a:bodyPr wrap="square" rtlCol="0" anchor="ctr"/>
           <a:lstStyle/>
           <a:p>
-            <a:pPr algn="ctr" indent="0" marL="0">
+            <a:pPr marL="0" indent="0" algn="ctr">
               <a:buNone/>
             </a:pPr>
             <a:r>
@@ -5069,6 +4931,13 @@
             <a:tailEnd type="triangle"/>
           </a:ln>
         </p:spPr>
+        <p:txBody>
+          <a:bodyPr/>
+          <a:lstStyle/>
+          <a:p>
+            <a:endParaRPr lang="es-ES"/>
+          </a:p>
+        </p:txBody>
       </p:sp>
       <p:sp>
         <p:nvSpPr>
@@ -5091,7 +4960,7 @@
           <a:bodyPr wrap="square" rtlCol="0" anchor="ctr"/>
           <a:lstStyle/>
           <a:p>
-            <a:pPr algn="ctr" indent="0" marL="0">
+            <a:pPr marL="0" indent="0" algn="ctr">
               <a:buNone/>
             </a:pPr>
             <a:r>
@@ -5132,6 +5001,13 @@
             <a:tailEnd type="triangle"/>
           </a:ln>
         </p:spPr>
+        <p:txBody>
+          <a:bodyPr/>
+          <a:lstStyle/>
+          <a:p>
+            <a:endParaRPr lang="es-ES"/>
+          </a:p>
+        </p:txBody>
       </p:sp>
       <p:sp>
         <p:nvSpPr>
@@ -5141,7 +5017,7 @@
         </p:nvSpPr>
         <p:spPr>
           <a:xfrm>
-            <a:off x="5074920" y="3154680"/>
+            <a:off x="4526280" y="2899954"/>
             <a:ext cx="2148840" cy="274320"/>
           </a:xfrm>
           <a:prstGeom prst="rect">
@@ -5154,7 +5030,7 @@
           <a:bodyPr wrap="square" rtlCol="0" anchor="ctr"/>
           <a:lstStyle/>
           <a:p>
-            <a:pPr algn="ctr" indent="0" marL="0">
+            <a:pPr marL="0" indent="0" algn="ctr">
               <a:buNone/>
             </a:pPr>
             <a:r>
@@ -5195,6 +5071,13 @@
             <a:tailEnd type="triangle"/>
           </a:ln>
         </p:spPr>
+        <p:txBody>
+          <a:bodyPr/>
+          <a:lstStyle/>
+          <a:p>
+            <a:endParaRPr lang="es-ES"/>
+          </a:p>
+        </p:txBody>
       </p:sp>
       <p:sp>
         <p:nvSpPr>
@@ -5204,7 +5087,7 @@
         </p:nvSpPr>
         <p:spPr>
           <a:xfrm>
-            <a:off x="5349240" y="4343400"/>
+            <a:off x="5600700" y="4170317"/>
             <a:ext cx="1737360" cy="274320"/>
           </a:xfrm>
           <a:prstGeom prst="rect">
@@ -5217,7 +5100,7 @@
           <a:bodyPr wrap="square" rtlCol="0" anchor="ctr"/>
           <a:lstStyle/>
           <a:p>
-            <a:pPr algn="ctr" indent="0" marL="0">
+            <a:pPr marL="0" indent="0" algn="ctr">
               <a:buNone/>
             </a:pPr>
             <a:r>
@@ -5259,6 +5142,13 @@
             <a:prstDash val="solid"/>
           </a:ln>
         </p:spPr>
+        <p:txBody>
+          <a:bodyPr/>
+          <a:lstStyle/>
+          <a:p>
+            <a:endParaRPr lang="es-ES"/>
+          </a:p>
+        </p:txBody>
       </p:sp>
       <p:sp>
         <p:nvSpPr>
@@ -5281,7 +5171,7 @@
           <a:bodyPr wrap="square" rtlCol="0" anchor="ctr"/>
           <a:lstStyle/>
           <a:p>
-            <a:pPr indent="0" marL="0">
+            <a:pPr marL="0" indent="0">
               <a:buNone/>
             </a:pPr>
             <a:r>
@@ -5320,7 +5210,7 @@
           <a:bodyPr wrap="square" rtlCol="0" anchor="ctr"/>
           <a:lstStyle/>
           <a:p>
-            <a:pPr algn="r" indent="0" marL="0">
+            <a:pPr marL="0" indent="0" algn="r">
               <a:buNone/>
             </a:pPr>
             <a:r>
@@ -5387,6 +5277,13 @@
             <a:prstDash val="solid"/>
           </a:ln>
         </p:spPr>
+        <p:txBody>
+          <a:bodyPr/>
+          <a:lstStyle/>
+          <a:p>
+            <a:endParaRPr lang="es-ES"/>
+          </a:p>
+        </p:txBody>
       </p:sp>
       <p:sp>
         <p:nvSpPr>
@@ -5409,7 +5306,7 @@
           <a:bodyPr wrap="square" rtlCol="0" anchor="ctr"/>
           <a:lstStyle/>
           <a:p>
-            <a:pPr indent="0" marL="0">
+            <a:pPr marL="0" indent="0">
               <a:buNone/>
             </a:pPr>
             <a:r>
@@ -5448,7 +5345,7 @@
           <a:bodyPr wrap="square" rtlCol="0" anchor="t"/>
           <a:lstStyle/>
           <a:p>
-            <a:pPr indent="0" marL="0">
+            <a:pPr marL="0" indent="0">
               <a:spcAft>
                 <a:spcPts val="800"/>
               </a:spcAft>
@@ -5468,7 +5365,7 @@
             <a:endParaRPr lang="en-US" sz="1700" dirty="0"/>
           </a:p>
           <a:p>
-            <a:pPr indent="0" marL="0">
+            <a:pPr marL="0" indent="0">
               <a:spcAft>
                 <a:spcPts val="800"/>
               </a:spcAft>
@@ -5510,17 +5407,24 @@
             <a:prstDash val="solid"/>
           </a:ln>
         </p:spPr>
+        <p:txBody>
+          <a:bodyPr/>
+          <a:lstStyle/>
+          <a:p>
+            <a:endParaRPr lang="es-ES"/>
+          </a:p>
+        </p:txBody>
       </p:sp>
       <p:pic>
         <p:nvPicPr>
-          <p:cNvPr id="6" name="Image 0" descr="C:/Users/Aitor/Documents/apuntes-profe/entornos-de-desarrollo/docs/tema6/img/comunicacion-lavadora.png">    </p:cNvPr>
+          <p:cNvPr id="6" name="Image 0" descr="C:/Users/Aitor/Documents/apuntes-profe/entornos-de-desarrollo/docs/tema6/img/comunicacion-lavadora.png"/>
           <p:cNvPicPr>
             <a:picLocks noChangeAspect="1"/>
           </p:cNvPicPr>
           <p:nvPr/>
         </p:nvPicPr>
         <p:blipFill>
-          <a:blip r:embed="rId1"/>
+          <a:blip r:embed="rId3"/>
           <a:stretch>
             <a:fillRect/>
           </a:stretch>
@@ -5556,7 +5460,7 @@
           <a:bodyPr wrap="square" rtlCol="0" anchor="t"/>
           <a:lstStyle/>
           <a:p>
-            <a:pPr algn="ctr" indent="0" marL="0">
+            <a:pPr marL="0" indent="0" algn="ctr">
               <a:buNone/>
             </a:pPr>
             <a:r>
@@ -5595,7 +5499,7 @@
           <a:bodyPr wrap="square" rtlCol="0" anchor="ctr"/>
           <a:lstStyle/>
           <a:p>
-            <a:pPr algn="r" indent="0" marL="0">
+            <a:pPr marL="0" indent="0" algn="r">
               <a:buNone/>
             </a:pPr>
             <a:r>
@@ -5662,6 +5566,13 @@
             <a:prstDash val="solid"/>
           </a:ln>
         </p:spPr>
+        <p:txBody>
+          <a:bodyPr/>
+          <a:lstStyle/>
+          <a:p>
+            <a:endParaRPr lang="es-ES"/>
+          </a:p>
+        </p:txBody>
       </p:sp>
       <p:sp>
         <p:nvSpPr>
@@ -5684,7 +5595,7 @@
           <a:bodyPr wrap="square" rtlCol="0" anchor="ctr"/>
           <a:lstStyle/>
           <a:p>
-            <a:pPr indent="0" marL="0">
+            <a:pPr marL="0" indent="0">
               <a:buNone/>
             </a:pPr>
             <a:r>
@@ -5710,8 +5621,8 @@
         </p:nvSpPr>
         <p:spPr>
           <a:xfrm>
-            <a:off x="548640" y="1051560"/>
-            <a:ext cx="5760720" cy="2926080"/>
+            <a:off x="548639" y="1051560"/>
+            <a:ext cx="10564119" cy="2926080"/>
           </a:xfrm>
           <a:prstGeom prst="rect">
             <a:avLst/>
@@ -5723,7 +5634,7 @@
           <a:bodyPr wrap="square" rtlCol="0" anchor="t"/>
           <a:lstStyle/>
           <a:p>
-            <a:pPr indent="0" marL="0">
+            <a:pPr marL="0" indent="0">
               <a:spcAft>
                 <a:spcPts val="800"/>
               </a:spcAft>
@@ -5743,7 +5654,7 @@
             <a:endParaRPr lang="en-US" sz="1500" dirty="0"/>
           </a:p>
           <a:p>
-            <a:pPr indent="0" marL="0">
+            <a:pPr marL="0" indent="0">
               <a:spcAft>
                 <a:spcPts val="800"/>
               </a:spcAft>
@@ -5763,7 +5674,7 @@
             <a:endParaRPr lang="en-US" sz="1500" dirty="0"/>
           </a:p>
           <a:p>
-            <a:pPr indent="0" marL="0">
+            <a:pPr marL="0" indent="0">
               <a:spcAft>
                 <a:spcPts val="800"/>
               </a:spcAft>
@@ -5786,22 +5697,22 @@
       </p:sp>
       <p:pic>
         <p:nvPicPr>
-          <p:cNvPr id="5" name="Image 0" descr="C:/Users/Aitor/Documents/apuntes-profe/entornos-de-desarrollo/docs/tema6/img/comunicacion-lavadora.png">    </p:cNvPr>
+          <p:cNvPr id="5" name="Image 0" descr="C:/Users/Aitor/Documents/apuntes-profe/entornos-de-desarrollo/docs/tema6/img/comunicacion-lavadora.png"/>
           <p:cNvPicPr>
             <a:picLocks noChangeAspect="1"/>
           </p:cNvPicPr>
           <p:nvPr/>
         </p:nvPicPr>
         <p:blipFill>
-          <a:blip r:embed="rId1"/>
+          <a:blip r:embed="rId3"/>
           <a:stretch>
             <a:fillRect/>
           </a:stretch>
         </p:blipFill>
         <p:spPr>
           <a:xfrm>
-            <a:off x="6583680" y="1051560"/>
-            <a:ext cx="5029200" cy="3108960"/>
+            <a:off x="6510465" y="2439955"/>
+            <a:ext cx="5129847" cy="3764902"/>
           </a:xfrm>
           <a:prstGeom prst="rect">
             <a:avLst/>
@@ -5810,39 +5721,14 @@
       </p:pic>
       <p:sp>
         <p:nvSpPr>
-          <p:cNvPr id="6" name="Shape 3"/>
-          <p:cNvSpPr/>
-          <p:nvPr/>
-        </p:nvSpPr>
-        <p:spPr>
-          <a:xfrm>
-            <a:off x="548640" y="4572000"/>
-            <a:ext cx="11091672" cy="1188720"/>
-          </a:xfrm>
-          <a:prstGeom prst="roundRect">
-            <a:avLst/>
-          </a:prstGeom>
-          <a:solidFill>
-            <a:srgbClr val="E0F2F1"/>
-          </a:solidFill>
-          <a:ln w="19050">
-            <a:solidFill>
-              <a:srgbClr val="009688"/>
-            </a:solidFill>
-            <a:prstDash val="solid"/>
-          </a:ln>
-        </p:spPr>
-      </p:sp>
-      <p:sp>
-        <p:nvSpPr>
-          <p:cNvPr id="7" name="Text 4"/>
-          <p:cNvSpPr/>
-          <p:nvPr/>
-        </p:nvSpPr>
-        <p:spPr>
-          <a:xfrm>
-            <a:off x="777240" y="4645152"/>
-            <a:ext cx="10634472" cy="1042416"/>
+          <p:cNvPr id="8" name="Text 5"/>
+          <p:cNvSpPr/>
+          <p:nvPr/>
+        </p:nvSpPr>
+        <p:spPr>
+          <a:xfrm>
+            <a:off x="548640" y="6473952"/>
+            <a:ext cx="11091672" cy="292608"/>
           </a:xfrm>
           <a:prstGeom prst="rect">
             <a:avLst/>
@@ -5854,46 +5740,7 @@
           <a:bodyPr wrap="square" rtlCol="0" anchor="ctr"/>
           <a:lstStyle/>
           <a:p>
-            <a:pPr indent="0" marL="0">
-              <a:buNone/>
-            </a:pPr>
-            <a:r>
-              <a:rPr lang="en-US" sz="1400" dirty="0">
-                <a:solidFill>
-                  <a:srgbClr val="212121"/>
-                </a:solidFill>
-                <a:latin typeface="Arial" pitchFamily="34" charset="0"/>
-                <a:ea typeface="Arial" pitchFamily="34" charset="-122"/>
-                <a:cs typeface="Arial" pitchFamily="34" charset="-120"/>
-              </a:rPr>
-              <a:t>El paso inverso también funciona: la numeración te da el orden vertical. En la práctica, el de secuencia es más habitual; el de comunicación gana con muchos objetos, cuando lo que preocupa es la estructura de conexiones (p. ej., detectar que un objeto habla con demasiados).</a:t>
-            </a:r>
-            <a:endParaRPr lang="en-US" sz="1400" dirty="0"/>
-          </a:p>
-        </p:txBody>
-      </p:sp>
-      <p:sp>
-        <p:nvSpPr>
-          <p:cNvPr id="8" name="Text 5"/>
-          <p:cNvSpPr/>
-          <p:nvPr/>
-        </p:nvSpPr>
-        <p:spPr>
-          <a:xfrm>
-            <a:off x="548640" y="6473952"/>
-            <a:ext cx="11091672" cy="292608"/>
-          </a:xfrm>
-          <a:prstGeom prst="rect">
-            <a:avLst/>
-          </a:prstGeom>
-          <a:noFill/>
-          <a:ln/>
-        </p:spPr>
-        <p:txBody>
-          <a:bodyPr wrap="square" rtlCol="0" anchor="ctr"/>
-          <a:lstStyle/>
-          <a:p>
-            <a:pPr algn="r" indent="0" marL="0">
+            <a:pPr marL="0" indent="0" algn="r">
               <a:buNone/>
             </a:pPr>
             <a:r>
@@ -5911,6 +5758,36 @@
           </a:p>
         </p:txBody>
       </p:sp>
+      <p:pic>
+        <p:nvPicPr>
+          <p:cNvPr id="9" name="Image 0" descr="C:/Users/Aitor/Documents/apuntes-profe/entornos-de-desarrollo/docs/tema6/img/secuencia-lavadora-completo.png">
+            <a:extLst>
+              <a:ext uri="{FF2B5EF4-FFF2-40B4-BE49-F238E27FC236}">
+                <a16:creationId xmlns:a16="http://schemas.microsoft.com/office/drawing/2014/main" id="{121D0F3E-DA80-5C68-E9D1-FD2B64BC231D}"/>
+              </a:ext>
+            </a:extLst>
+          </p:cNvPr>
+          <p:cNvPicPr>
+            <a:picLocks noChangeAspect="1"/>
+          </p:cNvPicPr>
+          <p:nvPr/>
+        </p:nvPicPr>
+        <p:blipFill>
+          <a:blip r:embed="rId4"/>
+          <a:stretch>
+            <a:fillRect/>
+          </a:stretch>
+        </p:blipFill>
+        <p:spPr>
+          <a:xfrm>
+            <a:off x="701840" y="2416815"/>
+            <a:ext cx="5392636" cy="3922589"/>
+          </a:xfrm>
+          <a:prstGeom prst="rect">
+            <a:avLst/>
+          </a:prstGeom>
+        </p:spPr>
+      </p:pic>
     </p:spTree>
   </p:cSld>
   <p:clrMapOvr>
@@ -5960,6 +5837,13 @@
             <a:prstDash val="solid"/>
           </a:ln>
         </p:spPr>
+        <p:txBody>
+          <a:bodyPr/>
+          <a:lstStyle/>
+          <a:p>
+            <a:endParaRPr lang="es-ES"/>
+          </a:p>
+        </p:txBody>
       </p:sp>
       <p:sp>
         <p:nvSpPr>
@@ -5982,7 +5866,7 @@
           <a:bodyPr wrap="square" rtlCol="0" anchor="ctr"/>
           <a:lstStyle/>
           <a:p>
-            <a:pPr indent="0" marL="0">
+            <a:pPr marL="0" indent="0">
               <a:buNone/>
             </a:pPr>
             <a:r>
@@ -6021,7 +5905,7 @@
           <a:bodyPr wrap="square" rtlCol="0" anchor="t"/>
           <a:lstStyle/>
           <a:p>
-            <a:pPr indent="0" marL="0">
+            <a:pPr marL="0" indent="0">
               <a:spcAft>
                 <a:spcPts val="800"/>
               </a:spcAft>
@@ -6066,6 +5950,13 @@
             <a:prstDash val="solid"/>
           </a:ln>
         </p:spPr>
+        <p:txBody>
+          <a:bodyPr/>
+          <a:lstStyle/>
+          <a:p>
+            <a:endParaRPr lang="es-ES"/>
+          </a:p>
+        </p:txBody>
       </p:sp>
       <p:sp>
         <p:nvSpPr>
@@ -6088,7 +5979,7 @@
           <a:bodyPr wrap="square" rtlCol="0" anchor="ctr"/>
           <a:lstStyle/>
           <a:p>
-            <a:pPr algn="ctr" indent="0" marL="0">
+            <a:pPr marL="0" indent="0" algn="ctr">
               <a:buNone/>
             </a:pPr>
             <a:r>
@@ -6130,6 +6021,13 @@
             <a:prstDash val="solid"/>
           </a:ln>
         </p:spPr>
+        <p:txBody>
+          <a:bodyPr/>
+          <a:lstStyle/>
+          <a:p>
+            <a:endParaRPr lang="es-ES"/>
+          </a:p>
+        </p:txBody>
       </p:sp>
       <p:sp>
         <p:nvSpPr>
@@ -6152,7 +6050,7 @@
           <a:bodyPr wrap="square" rtlCol="0" anchor="ctr"/>
           <a:lstStyle/>
           <a:p>
-            <a:pPr algn="ctr" indent="0" marL="0">
+            <a:pPr marL="0" indent="0" algn="ctr">
               <a:buNone/>
             </a:pPr>
             <a:r>
@@ -6194,6 +6092,13 @@
             <a:prstDash val="solid"/>
           </a:ln>
         </p:spPr>
+        <p:txBody>
+          <a:bodyPr/>
+          <a:lstStyle/>
+          <a:p>
+            <a:endParaRPr lang="es-ES"/>
+          </a:p>
+        </p:txBody>
       </p:sp>
       <p:sp>
         <p:nvSpPr>
@@ -6216,7 +6121,7 @@
           <a:bodyPr wrap="square" rtlCol="0" anchor="ctr"/>
           <a:lstStyle/>
           <a:p>
-            <a:pPr algn="ctr" indent="0" marL="0">
+            <a:pPr marL="0" indent="0" algn="ctr">
               <a:buNone/>
             </a:pPr>
             <a:r>
@@ -6256,6 +6161,13 @@
             <a:prstDash val="dash"/>
           </a:ln>
         </p:spPr>
+        <p:txBody>
+          <a:bodyPr/>
+          <a:lstStyle/>
+          <a:p>
+            <a:endParaRPr lang="es-ES"/>
+          </a:p>
+        </p:txBody>
       </p:sp>
       <p:sp>
         <p:nvSpPr>
@@ -6279,6 +6191,13 @@
             <a:prstDash val="dash"/>
           </a:ln>
         </p:spPr>
+        <p:txBody>
+          <a:bodyPr/>
+          <a:lstStyle/>
+          <a:p>
+            <a:endParaRPr lang="es-ES"/>
+          </a:p>
+        </p:txBody>
       </p:sp>
       <p:sp>
         <p:nvSpPr>
@@ -6302,6 +6221,13 @@
             <a:prstDash val="dash"/>
           </a:ln>
         </p:spPr>
+        <p:txBody>
+          <a:bodyPr/>
+          <a:lstStyle/>
+          <a:p>
+            <a:endParaRPr lang="es-ES"/>
+          </a:p>
+        </p:txBody>
       </p:sp>
       <p:sp>
         <p:nvSpPr>
@@ -6327,6 +6253,13 @@
             <a:prstDash val="solid"/>
           </a:ln>
         </p:spPr>
+        <p:txBody>
+          <a:bodyPr/>
+          <a:lstStyle/>
+          <a:p>
+            <a:endParaRPr lang="es-ES"/>
+          </a:p>
+        </p:txBody>
       </p:sp>
       <p:sp>
         <p:nvSpPr>
@@ -6352,6 +6285,13 @@
             <a:prstDash val="solid"/>
           </a:ln>
         </p:spPr>
+        <p:txBody>
+          <a:bodyPr/>
+          <a:lstStyle/>
+          <a:p>
+            <a:endParaRPr lang="es-ES"/>
+          </a:p>
+        </p:txBody>
       </p:sp>
       <p:sp>
         <p:nvSpPr>
@@ -6377,6 +6317,13 @@
             <a:prstDash val="solid"/>
           </a:ln>
         </p:spPr>
+        <p:txBody>
+          <a:bodyPr/>
+          <a:lstStyle/>
+          <a:p>
+            <a:endParaRPr lang="es-ES"/>
+          </a:p>
+        </p:txBody>
       </p:sp>
       <p:sp>
         <p:nvSpPr>
@@ -6401,6 +6348,13 @@
             <a:tailEnd type="triangle"/>
           </a:ln>
         </p:spPr>
+        <p:txBody>
+          <a:bodyPr/>
+          <a:lstStyle/>
+          <a:p>
+            <a:endParaRPr lang="es-ES"/>
+          </a:p>
+        </p:txBody>
       </p:sp>
       <p:sp>
         <p:nvSpPr>
@@ -6423,7 +6377,7 @@
           <a:bodyPr wrap="square" rtlCol="0" anchor="ctr"/>
           <a:lstStyle/>
           <a:p>
-            <a:pPr algn="ctr" indent="0" marL="0">
+            <a:pPr marL="0" indent="0" algn="ctr">
               <a:buNone/>
             </a:pPr>
             <a:r>
@@ -6464,6 +6418,13 @@
             <a:tailEnd type="triangle"/>
           </a:ln>
         </p:spPr>
+        <p:txBody>
+          <a:bodyPr/>
+          <a:lstStyle/>
+          <a:p>
+            <a:endParaRPr lang="es-ES"/>
+          </a:p>
+        </p:txBody>
       </p:sp>
       <p:sp>
         <p:nvSpPr>
@@ -6486,7 +6447,7 @@
           <a:bodyPr wrap="square" rtlCol="0" anchor="ctr"/>
           <a:lstStyle/>
           <a:p>
-            <a:pPr algn="ctr" indent="0" marL="0">
+            <a:pPr marL="0" indent="0" algn="ctr">
               <a:buNone/>
             </a:pPr>
             <a:r>
@@ -6527,6 +6488,13 @@
             <a:tailEnd type="triangle"/>
           </a:ln>
         </p:spPr>
+        <p:txBody>
+          <a:bodyPr/>
+          <a:lstStyle/>
+          <a:p>
+            <a:endParaRPr lang="es-ES"/>
+          </a:p>
+        </p:txBody>
       </p:sp>
       <p:sp>
         <p:nvSpPr>
@@ -6549,7 +6517,7 @@
           <a:bodyPr wrap="square" rtlCol="0" anchor="ctr"/>
           <a:lstStyle/>
           <a:p>
-            <a:pPr algn="ctr" indent="0" marL="0">
+            <a:pPr marL="0" indent="0" algn="ctr">
               <a:buNone/>
             </a:pPr>
             <a:r>
@@ -6590,6 +6558,13 @@
             <a:tailEnd type="triangle"/>
           </a:ln>
         </p:spPr>
+        <p:txBody>
+          <a:bodyPr/>
+          <a:lstStyle/>
+          <a:p>
+            <a:endParaRPr lang="es-ES"/>
+          </a:p>
+        </p:txBody>
       </p:sp>
       <p:sp>
         <p:nvSpPr>
@@ -6612,7 +6587,7 @@
           <a:bodyPr wrap="square" rtlCol="0" anchor="ctr"/>
           <a:lstStyle/>
           <a:p>
-            <a:pPr algn="ctr" indent="0" marL="0">
+            <a:pPr marL="0" indent="0" algn="ctr">
               <a:buNone/>
             </a:pPr>
             <a:r>
@@ -6653,6 +6628,13 @@
             <a:tailEnd type="triangle"/>
           </a:ln>
         </p:spPr>
+        <p:txBody>
+          <a:bodyPr/>
+          <a:lstStyle/>
+          <a:p>
+            <a:endParaRPr lang="es-ES"/>
+          </a:p>
+        </p:txBody>
       </p:sp>
       <p:sp>
         <p:nvSpPr>
@@ -6675,7 +6657,7 @@
           <a:bodyPr wrap="square" rtlCol="0" anchor="ctr"/>
           <a:lstStyle/>
           <a:p>
-            <a:pPr algn="ctr" indent="0" marL="0">
+            <a:pPr marL="0" indent="0" algn="ctr">
               <a:buNone/>
             </a:pPr>
             <a:r>
@@ -6714,7 +6696,7 @@
           <a:bodyPr wrap="square" rtlCol="0" anchor="ctr"/>
           <a:lstStyle/>
           <a:p>
-            <a:pPr algn="r" indent="0" marL="0">
+            <a:pPr marL="0" indent="0" algn="r">
               <a:buNone/>
             </a:pPr>
             <a:r>
@@ -6781,6 +6763,13 @@
             <a:prstDash val="solid"/>
           </a:ln>
         </p:spPr>
+        <p:txBody>
+          <a:bodyPr/>
+          <a:lstStyle/>
+          <a:p>
+            <a:endParaRPr lang="es-ES"/>
+          </a:p>
+        </p:txBody>
       </p:sp>
       <p:sp>
         <p:nvSpPr>
@@ -6803,7 +6792,7 @@
           <a:bodyPr wrap="square" rtlCol="0" anchor="ctr"/>
           <a:lstStyle/>
           <a:p>
-            <a:pPr indent="0" marL="0">
+            <a:pPr marL="0" indent="0">
               <a:buNone/>
             </a:pPr>
             <a:r>
@@ -6845,6 +6834,13 @@
             <a:prstDash val="solid"/>
           </a:ln>
         </p:spPr>
+        <p:txBody>
+          <a:bodyPr/>
+          <a:lstStyle/>
+          <a:p>
+            <a:endParaRPr lang="es-ES"/>
+          </a:p>
+        </p:txBody>
       </p:sp>
       <p:sp>
         <p:nvSpPr>
@@ -6867,7 +6863,7 @@
           <a:bodyPr wrap="square" rtlCol="0" anchor="ctr"/>
           <a:lstStyle/>
           <a:p>
-            <a:pPr algn="ctr" indent="0" marL="0">
+            <a:pPr marL="0" indent="0" algn="ctr">
               <a:buNone/>
             </a:pPr>
             <a:r>
@@ -6909,6 +6905,13 @@
             <a:prstDash val="solid"/>
           </a:ln>
         </p:spPr>
+        <p:txBody>
+          <a:bodyPr/>
+          <a:lstStyle/>
+          <a:p>
+            <a:endParaRPr lang="es-ES"/>
+          </a:p>
+        </p:txBody>
       </p:sp>
       <p:sp>
         <p:nvSpPr>
@@ -6931,7 +6934,7 @@
           <a:bodyPr wrap="square" rtlCol="0" anchor="ctr"/>
           <a:lstStyle/>
           <a:p>
-            <a:pPr algn="ctr" indent="0" marL="0">
+            <a:pPr marL="0" indent="0" algn="ctr">
               <a:buNone/>
             </a:pPr>
             <a:r>
@@ -6973,6 +6976,13 @@
             <a:prstDash val="solid"/>
           </a:ln>
         </p:spPr>
+        <p:txBody>
+          <a:bodyPr/>
+          <a:lstStyle/>
+          <a:p>
+            <a:endParaRPr lang="es-ES"/>
+          </a:p>
+        </p:txBody>
       </p:sp>
       <p:sp>
         <p:nvSpPr>
@@ -6995,7 +7005,7 @@
           <a:bodyPr wrap="square" rtlCol="0" anchor="ctr"/>
           <a:lstStyle/>
           <a:p>
-            <a:pPr algn="ctr" indent="0" marL="0">
+            <a:pPr marL="0" indent="0" algn="ctr">
               <a:buNone/>
             </a:pPr>
             <a:r>
@@ -7037,6 +7047,13 @@
             <a:prstDash val="solid"/>
           </a:ln>
         </p:spPr>
+        <p:txBody>
+          <a:bodyPr/>
+          <a:lstStyle/>
+          <a:p>
+            <a:endParaRPr lang="es-ES"/>
+          </a:p>
+        </p:txBody>
       </p:sp>
       <p:sp>
         <p:nvSpPr>
@@ -7059,7 +7076,7 @@
           <a:bodyPr wrap="square" rtlCol="0" anchor="ctr"/>
           <a:lstStyle/>
           <a:p>
-            <a:pPr algn="ctr" indent="0" marL="0">
+            <a:pPr marL="0" indent="0" algn="ctr">
               <a:buNone/>
             </a:pPr>
             <a:r>
@@ -7100,6 +7117,13 @@
             <a:tailEnd type="triangle"/>
           </a:ln>
         </p:spPr>
+        <p:txBody>
+          <a:bodyPr/>
+          <a:lstStyle/>
+          <a:p>
+            <a:endParaRPr lang="es-ES"/>
+          </a:p>
+        </p:txBody>
       </p:sp>
       <p:sp>
         <p:nvSpPr>
@@ -7122,7 +7146,7 @@
           <a:bodyPr wrap="square" rtlCol="0" anchor="ctr"/>
           <a:lstStyle/>
           <a:p>
-            <a:pPr algn="ctr" indent="0" marL="0">
+            <a:pPr marL="0" indent="0" algn="ctr">
               <a:buNone/>
             </a:pPr>
             <a:r>
@@ -7163,6 +7187,13 @@
             <a:tailEnd type="triangle"/>
           </a:ln>
         </p:spPr>
+        <p:txBody>
+          <a:bodyPr/>
+          <a:lstStyle/>
+          <a:p>
+            <a:endParaRPr lang="es-ES"/>
+          </a:p>
+        </p:txBody>
       </p:sp>
       <p:sp>
         <p:nvSpPr>
@@ -7172,7 +7203,7 @@
         </p:nvSpPr>
         <p:spPr>
           <a:xfrm>
-            <a:off x="5074920" y="1600200"/>
+            <a:off x="5532120" y="1924625"/>
             <a:ext cx="2148840" cy="274320"/>
           </a:xfrm>
           <a:prstGeom prst="rect">
@@ -7185,7 +7216,7 @@
           <a:bodyPr wrap="square" rtlCol="0" anchor="ctr"/>
           <a:lstStyle/>
           <a:p>
-            <a:pPr algn="ctr" indent="0" marL="0">
+            <a:pPr marL="0" indent="0" algn="ctr">
               <a:buNone/>
             </a:pPr>
             <a:r>
@@ -7226,6 +7257,13 @@
             <a:tailEnd type="triangle"/>
           </a:ln>
         </p:spPr>
+        <p:txBody>
+          <a:bodyPr/>
+          <a:lstStyle/>
+          <a:p>
+            <a:endParaRPr lang="es-ES"/>
+          </a:p>
+        </p:txBody>
       </p:sp>
       <p:sp>
         <p:nvSpPr>
@@ -7235,7 +7273,7 @@
         </p:nvSpPr>
         <p:spPr>
           <a:xfrm>
-            <a:off x="5349240" y="2788920"/>
+            <a:off x="5551248" y="2706250"/>
             <a:ext cx="1737360" cy="274320"/>
           </a:xfrm>
           <a:prstGeom prst="rect">
@@ -7248,7 +7286,7 @@
           <a:bodyPr wrap="square" rtlCol="0" anchor="ctr"/>
           <a:lstStyle/>
           <a:p>
-            <a:pPr algn="ctr" indent="0" marL="0">
+            <a:pPr marL="0" indent="0" algn="ctr">
               <a:buNone/>
             </a:pPr>
             <a:r>
@@ -7290,6 +7328,13 @@
             <a:prstDash val="solid"/>
           </a:ln>
         </p:spPr>
+        <p:txBody>
+          <a:bodyPr/>
+          <a:lstStyle/>
+          <a:p>
+            <a:endParaRPr lang="es-ES"/>
+          </a:p>
+        </p:txBody>
       </p:sp>
       <p:sp>
         <p:nvSpPr>
@@ -7312,7 +7357,7 @@
           <a:bodyPr wrap="square" rtlCol="0" anchor="ctr"/>
           <a:lstStyle/>
           <a:p>
-            <a:pPr indent="0" marL="0">
+            <a:pPr marL="0" indent="0">
               <a:buNone/>
             </a:pPr>
             <a:r>
@@ -7354,6 +7399,13 @@
             <a:prstDash val="solid"/>
           </a:ln>
         </p:spPr>
+        <p:txBody>
+          <a:bodyPr/>
+          <a:lstStyle/>
+          <a:p>
+            <a:endParaRPr lang="es-ES"/>
+          </a:p>
+        </p:txBody>
       </p:sp>
       <p:sp>
         <p:nvSpPr>
@@ -7376,7 +7428,7 @@
           <a:bodyPr wrap="square" rtlCol="0" anchor="ctr"/>
           <a:lstStyle/>
           <a:p>
-            <a:pPr indent="0" marL="0">
+            <a:pPr marL="0" indent="0">
               <a:buNone/>
             </a:pPr>
             <a:r>
@@ -7415,7 +7467,7 @@
           <a:bodyPr wrap="square" rtlCol="0" anchor="ctr"/>
           <a:lstStyle/>
           <a:p>
-            <a:pPr algn="r" indent="0" marL="0">
+            <a:pPr marL="0" indent="0" algn="r">
               <a:buNone/>
             </a:pPr>
             <a:r>
@@ -7482,6 +7534,13 @@
             <a:prstDash val="solid"/>
           </a:ln>
         </p:spPr>
+        <p:txBody>
+          <a:bodyPr/>
+          <a:lstStyle/>
+          <a:p>
+            <a:endParaRPr lang="es-ES"/>
+          </a:p>
+        </p:txBody>
       </p:sp>
       <p:sp>
         <p:nvSpPr>
@@ -7504,7 +7563,7 @@
           <a:bodyPr wrap="square" rtlCol="0" anchor="ctr"/>
           <a:lstStyle/>
           <a:p>
-            <a:pPr indent="0" marL="0">
+            <a:pPr marL="0" indent="0">
               <a:buNone/>
             </a:pPr>
             <a:r>
@@ -7543,7 +7602,7 @@
           <a:bodyPr wrap="square" rtlCol="0" anchor="t"/>
           <a:lstStyle/>
           <a:p>
-            <a:pPr indent="0" marL="0">
+            <a:pPr marL="0" indent="0">
               <a:spcAft>
                 <a:spcPts val="800"/>
               </a:spcAft>
@@ -7563,7 +7622,7 @@
             <a:endParaRPr lang="en-US" sz="1700" dirty="0"/>
           </a:p>
           <a:p>
-            <a:pPr indent="0" marL="0">
+            <a:pPr marL="0" indent="0">
               <a:spcAft>
                 <a:spcPts val="800"/>
               </a:spcAft>
@@ -7586,7 +7645,7 @@
       </p:sp>
       <p:graphicFrame>
         <p:nvGraphicFramePr>
-          <p:cNvPr id="3" name="Table 0"/>
+          <p:cNvPr id="5" name="Table 0"/>
           <p:cNvGraphicFramePr>
             <a:graphicFrameLocks noGrp="1"/>
           </p:cNvGraphicFramePr>
@@ -7600,15 +7659,27 @@
         </p:nvGraphicFramePr>
         <p:xfrm>
           <a:off x="548640" y="2286000"/>
-          <a:ext cx="11091672" cy="914400"/>
+          <a:ext cx="11091672" cy="2331720"/>
         </p:xfrm>
         <a:graphic>
           <a:graphicData uri="http://schemas.openxmlformats.org/drawingml/2006/table">
             <a:tbl>
               <a:tblPr/>
               <a:tblGrid>
-                <a:gridCol w="2662001"/>
-                <a:gridCol w="8429671"/>
+                <a:gridCol w="2662001">
+                  <a:extLst>
+                    <a:ext uri="{9D8B030D-6E8A-4147-A177-3AD203B41FA5}">
+                      <a16:colId xmlns:a16="http://schemas.microsoft.com/office/drawing/2014/main" val="20000"/>
+                    </a:ext>
+                  </a:extLst>
+                </a:gridCol>
+                <a:gridCol w="8429671">
+                  <a:extLst>
+                    <a:ext uri="{9D8B030D-6E8A-4147-A177-3AD203B41FA5}">
+                      <a16:colId xmlns:a16="http://schemas.microsoft.com/office/drawing/2014/main" val="20001"/>
+                    </a:ext>
+                  </a:extLst>
+                </a:gridCol>
               </a:tblGrid>
               <a:tr h="777240">
                 <a:tc>
@@ -7616,7 +7687,7 @@
                     <a:bodyPr/>
                     <a:lstStyle/>
                     <a:p>
-                      <a:pPr algn="ctr" indent="0" marL="0">
+                      <a:pPr marL="0" indent="0" algn="ctr">
                         <a:buNone/>
                       </a:pPr>
                       <a:r>
@@ -7684,7 +7755,7 @@
                     <a:bodyPr/>
                     <a:lstStyle/>
                     <a:p>
-                      <a:pPr algn="ctr" indent="0" marL="0">
+                      <a:pPr marL="0" indent="0" algn="ctr">
                         <a:buNone/>
                       </a:pPr>
                       <a:r>
@@ -7747,6 +7818,11 @@
                     </a:solidFill>
                   </a:tcPr>
                 </a:tc>
+                <a:extLst>
+                  <a:ext uri="{0D108BD9-81ED-4DB2-BD59-A6C34878D82A}">
+                    <a16:rowId xmlns:a16="http://schemas.microsoft.com/office/drawing/2014/main" val="10000"/>
+                  </a:ext>
+                </a:extLst>
               </a:tr>
               <a:tr h="777240">
                 <a:tc>
@@ -7754,7 +7830,7 @@
                     <a:bodyPr/>
                     <a:lstStyle/>
                     <a:p>
-                      <a:pPr algn="l" indent="0" marL="0">
+                      <a:pPr marL="0" indent="0" algn="l">
                         <a:buNone/>
                       </a:pPr>
                       <a:r>
@@ -7822,7 +7898,7 @@
                     <a:bodyPr/>
                     <a:lstStyle/>
                     <a:p>
-                      <a:pPr algn="l" indent="0" marL="0">
+                      <a:pPr marL="0" indent="0" algn="l">
                         <a:buNone/>
                       </a:pPr>
                       <a:r>
@@ -7885,6 +7961,11 @@
                     </a:solidFill>
                   </a:tcPr>
                 </a:tc>
+                <a:extLst>
+                  <a:ext uri="{0D108BD9-81ED-4DB2-BD59-A6C34878D82A}">
+                    <a16:rowId xmlns:a16="http://schemas.microsoft.com/office/drawing/2014/main" val="10001"/>
+                  </a:ext>
+                </a:extLst>
               </a:tr>
               <a:tr h="777240">
                 <a:tc>
@@ -7892,7 +7973,7 @@
                     <a:bodyPr/>
                     <a:lstStyle/>
                     <a:p>
-                      <a:pPr algn="l" indent="0" marL="0">
+                      <a:pPr marL="0" indent="0" algn="l">
                         <a:buNone/>
                       </a:pPr>
                       <a:r>
@@ -7960,7 +8041,7 @@
                     <a:bodyPr/>
                     <a:lstStyle/>
                     <a:p>
-                      <a:pPr algn="l" indent="0" marL="0">
+                      <a:pPr marL="0" indent="0" algn="l">
                         <a:buNone/>
                       </a:pPr>
                       <a:r>
@@ -8023,6 +8104,11 @@
                     </a:solidFill>
                   </a:tcPr>
                 </a:tc>
+                <a:extLst>
+                  <a:ext uri="{0D108BD9-81ED-4DB2-BD59-A6C34878D82A}">
+                    <a16:rowId xmlns:a16="http://schemas.microsoft.com/office/drawing/2014/main" val="10002"/>
+                  </a:ext>
+                </a:extLst>
               </a:tr>
             </a:tbl>
           </a:graphicData>
@@ -8036,7 +8122,7 @@
         </p:nvSpPr>
         <p:spPr>
           <a:xfrm>
-            <a:off x="548640" y="4389120"/>
+            <a:off x="548640" y="5020056"/>
             <a:ext cx="11091672" cy="1051560"/>
           </a:xfrm>
           <a:prstGeom prst="roundRect">
@@ -8052,6 +8138,13 @@
             <a:prstDash val="solid"/>
           </a:ln>
         </p:spPr>
+        <p:txBody>
+          <a:bodyPr/>
+          <a:lstStyle/>
+          <a:p>
+            <a:endParaRPr lang="es-ES"/>
+          </a:p>
+        </p:txBody>
       </p:sp>
       <p:sp>
         <p:nvSpPr>
@@ -8061,7 +8154,7 @@
         </p:nvSpPr>
         <p:spPr>
           <a:xfrm>
-            <a:off x="777240" y="4462272"/>
+            <a:off x="842554" y="5093208"/>
             <a:ext cx="10634472" cy="905256"/>
           </a:xfrm>
           <a:prstGeom prst="rect">
@@ -8074,7 +8167,7 @@
           <a:bodyPr wrap="square" rtlCol="0" anchor="ctr"/>
           <a:lstStyle/>
           <a:p>
-            <a:pPr indent="0" marL="0">
+            <a:pPr marL="0" indent="0">
               <a:buNone/>
             </a:pPr>
             <a:r>
@@ -8113,7 +8206,7 @@
           <a:bodyPr wrap="square" rtlCol="0" anchor="ctr"/>
           <a:lstStyle/>
           <a:p>
-            <a:pPr algn="r" indent="0" marL="0">
+            <a:pPr marL="0" indent="0" algn="r">
               <a:buNone/>
             </a:pPr>
             <a:r>
@@ -8180,6 +8273,13 @@
             <a:prstDash val="solid"/>
           </a:ln>
         </p:spPr>
+        <p:txBody>
+          <a:bodyPr/>
+          <a:lstStyle/>
+          <a:p>
+            <a:endParaRPr lang="es-ES"/>
+          </a:p>
+        </p:txBody>
       </p:sp>
       <p:sp>
         <p:nvSpPr>
@@ -8202,7 +8302,7 @@
           <a:bodyPr wrap="square" rtlCol="0" anchor="ctr"/>
           <a:lstStyle/>
           <a:p>
-            <a:pPr indent="0" marL="0">
+            <a:pPr marL="0" indent="0">
               <a:buNone/>
             </a:pPr>
             <a:r>
@@ -8241,7 +8341,7 @@
           <a:bodyPr wrap="square" rtlCol="0" anchor="t"/>
           <a:lstStyle/>
           <a:p>
-            <a:pPr indent="0" marL="0">
+            <a:pPr marL="0" indent="0">
               <a:spcAft>
                 <a:spcPts val="800"/>
               </a:spcAft>
@@ -8286,6 +8386,13 @@
             <a:prstDash val="solid"/>
           </a:ln>
         </p:spPr>
+        <p:txBody>
+          <a:bodyPr/>
+          <a:lstStyle/>
+          <a:p>
+            <a:endParaRPr lang="es-ES"/>
+          </a:p>
+        </p:txBody>
       </p:sp>
       <p:sp>
         <p:nvSpPr>
@@ -8308,7 +8415,7 @@
           <a:bodyPr wrap="square" rtlCol="0" anchor="ctr"/>
           <a:lstStyle/>
           <a:p>
-            <a:pPr algn="ctr" indent="0" marL="0">
+            <a:pPr marL="0" indent="0" algn="ctr">
               <a:buNone/>
             </a:pPr>
             <a:r>
@@ -8350,6 +8457,13 @@
             <a:prstDash val="solid"/>
           </a:ln>
         </p:spPr>
+        <p:txBody>
+          <a:bodyPr/>
+          <a:lstStyle/>
+          <a:p>
+            <a:endParaRPr lang="es-ES"/>
+          </a:p>
+        </p:txBody>
       </p:sp>
       <p:sp>
         <p:nvSpPr>
@@ -8372,7 +8486,7 @@
           <a:bodyPr wrap="square" rtlCol="0" anchor="ctr"/>
           <a:lstStyle/>
           <a:p>
-            <a:pPr algn="ctr" indent="0" marL="0">
+            <a:pPr marL="0" indent="0" algn="ctr">
               <a:buNone/>
             </a:pPr>
             <a:r>
@@ -8414,6 +8528,13 @@
             <a:prstDash val="solid"/>
           </a:ln>
         </p:spPr>
+        <p:txBody>
+          <a:bodyPr/>
+          <a:lstStyle/>
+          <a:p>
+            <a:endParaRPr lang="es-ES"/>
+          </a:p>
+        </p:txBody>
       </p:sp>
       <p:sp>
         <p:nvSpPr>
@@ -8436,7 +8557,7 @@
           <a:bodyPr wrap="square" rtlCol="0" anchor="ctr"/>
           <a:lstStyle/>
           <a:p>
-            <a:pPr algn="ctr" indent="0" marL="0">
+            <a:pPr marL="0" indent="0" algn="ctr">
               <a:buNone/>
             </a:pPr>
             <a:r>
@@ -8476,6 +8597,13 @@
             <a:prstDash val="dash"/>
           </a:ln>
         </p:spPr>
+        <p:txBody>
+          <a:bodyPr/>
+          <a:lstStyle/>
+          <a:p>
+            <a:endParaRPr lang="es-ES"/>
+          </a:p>
+        </p:txBody>
       </p:sp>
       <p:sp>
         <p:nvSpPr>
@@ -8499,6 +8627,13 @@
             <a:prstDash val="dash"/>
           </a:ln>
         </p:spPr>
+        <p:txBody>
+          <a:bodyPr/>
+          <a:lstStyle/>
+          <a:p>
+            <a:endParaRPr lang="es-ES"/>
+          </a:p>
+        </p:txBody>
       </p:sp>
       <p:sp>
         <p:nvSpPr>
@@ -8522,6 +8657,13 @@
             <a:prstDash val="dash"/>
           </a:ln>
         </p:spPr>
+        <p:txBody>
+          <a:bodyPr/>
+          <a:lstStyle/>
+          <a:p>
+            <a:endParaRPr lang="es-ES"/>
+          </a:p>
+        </p:txBody>
       </p:sp>
       <p:sp>
         <p:nvSpPr>
@@ -8547,6 +8689,13 @@
             <a:prstDash val="solid"/>
           </a:ln>
         </p:spPr>
+        <p:txBody>
+          <a:bodyPr/>
+          <a:lstStyle/>
+          <a:p>
+            <a:endParaRPr lang="es-ES"/>
+          </a:p>
+        </p:txBody>
       </p:sp>
       <p:sp>
         <p:nvSpPr>
@@ -8572,6 +8721,13 @@
             <a:prstDash val="solid"/>
           </a:ln>
         </p:spPr>
+        <p:txBody>
+          <a:bodyPr/>
+          <a:lstStyle/>
+          <a:p>
+            <a:endParaRPr lang="es-ES"/>
+          </a:p>
+        </p:txBody>
       </p:sp>
       <p:sp>
         <p:nvSpPr>
@@ -8596,6 +8752,13 @@
             <a:tailEnd type="triangle"/>
           </a:ln>
         </p:spPr>
+        <p:txBody>
+          <a:bodyPr/>
+          <a:lstStyle/>
+          <a:p>
+            <a:endParaRPr lang="es-ES"/>
+          </a:p>
+        </p:txBody>
       </p:sp>
       <p:sp>
         <p:nvSpPr>
@@ -8618,7 +8781,7 @@
           <a:bodyPr wrap="square" rtlCol="0" anchor="ctr"/>
           <a:lstStyle/>
           <a:p>
-            <a:pPr algn="ctr" indent="0" marL="0">
+            <a:pPr marL="0" indent="0" algn="ctr">
               <a:buNone/>
             </a:pPr>
             <a:r>
@@ -8659,6 +8822,13 @@
             <a:tailEnd type="triangle"/>
           </a:ln>
         </p:spPr>
+        <p:txBody>
+          <a:bodyPr/>
+          <a:lstStyle/>
+          <a:p>
+            <a:endParaRPr lang="es-ES"/>
+          </a:p>
+        </p:txBody>
       </p:sp>
       <p:sp>
         <p:nvSpPr>
@@ -8681,7 +8851,7 @@
           <a:bodyPr wrap="square" rtlCol="0" anchor="ctr"/>
           <a:lstStyle/>
           <a:p>
-            <a:pPr algn="ctr" indent="0" marL="0">
+            <a:pPr marL="0" indent="0" algn="ctr">
               <a:buNone/>
             </a:pPr>
             <a:r>
@@ -8722,6 +8892,13 @@
             <a:tailEnd type="triangle"/>
           </a:ln>
         </p:spPr>
+        <p:txBody>
+          <a:bodyPr/>
+          <a:lstStyle/>
+          <a:p>
+            <a:endParaRPr lang="es-ES"/>
+          </a:p>
+        </p:txBody>
       </p:sp>
       <p:sp>
         <p:nvSpPr>
@@ -8744,7 +8921,7 @@
           <a:bodyPr wrap="square" rtlCol="0" anchor="ctr"/>
           <a:lstStyle/>
           <a:p>
-            <a:pPr algn="ctr" indent="0" marL="0">
+            <a:pPr marL="0" indent="0" algn="ctr">
               <a:buNone/>
             </a:pPr>
             <a:r>
@@ -8785,6 +8962,13 @@
             <a:tailEnd type="triangle"/>
           </a:ln>
         </p:spPr>
+        <p:txBody>
+          <a:bodyPr/>
+          <a:lstStyle/>
+          <a:p>
+            <a:endParaRPr lang="es-ES"/>
+          </a:p>
+        </p:txBody>
       </p:sp>
       <p:sp>
         <p:nvSpPr>
@@ -8807,7 +8991,7 @@
           <a:bodyPr wrap="square" rtlCol="0" anchor="ctr"/>
           <a:lstStyle/>
           <a:p>
-            <a:pPr algn="ctr" indent="0" marL="0">
+            <a:pPr marL="0" indent="0" algn="ctr">
               <a:buNone/>
             </a:pPr>
             <a:r>
@@ -8849,6 +9033,13 @@
             <a:prstDash val="solid"/>
           </a:ln>
         </p:spPr>
+        <p:txBody>
+          <a:bodyPr/>
+          <a:lstStyle/>
+          <a:p>
+            <a:endParaRPr lang="es-ES"/>
+          </a:p>
+        </p:txBody>
       </p:sp>
       <p:sp>
         <p:nvSpPr>
@@ -8871,7 +9062,7 @@
           <a:bodyPr wrap="square" rtlCol="0" anchor="ctr"/>
           <a:lstStyle/>
           <a:p>
-            <a:pPr indent="0" marL="0">
+            <a:pPr marL="0" indent="0">
               <a:buNone/>
             </a:pPr>
             <a:r>
@@ -8910,7 +9101,7 @@
           <a:bodyPr wrap="square" rtlCol="0" anchor="ctr"/>
           <a:lstStyle/>
           <a:p>
-            <a:pPr algn="r" indent="0" marL="0">
+            <a:pPr marL="0" indent="0" algn="r">
               <a:buNone/>
             </a:pPr>
             <a:r>
@@ -8977,6 +9168,13 @@
             <a:prstDash val="solid"/>
           </a:ln>
         </p:spPr>
+        <p:txBody>
+          <a:bodyPr/>
+          <a:lstStyle/>
+          <a:p>
+            <a:endParaRPr lang="es-ES"/>
+          </a:p>
+        </p:txBody>
       </p:sp>
       <p:sp>
         <p:nvSpPr>
@@ -8999,7 +9197,7 @@
           <a:bodyPr wrap="square" rtlCol="0" anchor="ctr"/>
           <a:lstStyle/>
           <a:p>
-            <a:pPr indent="0" marL="0">
+            <a:pPr marL="0" indent="0">
               <a:buNone/>
             </a:pPr>
             <a:r>
@@ -9033,16 +9231,34 @@
         </p:nvGraphicFramePr>
         <p:xfrm>
           <a:off x="548640" y="1188720"/>
-          <a:ext cx="11091672" cy="914400"/>
+          <a:ext cx="11091672" cy="3657600"/>
         </p:xfrm>
         <a:graphic>
           <a:graphicData uri="http://schemas.openxmlformats.org/drawingml/2006/table">
             <a:tbl>
               <a:tblPr/>
               <a:tblGrid>
-                <a:gridCol w="1996501"/>
-                <a:gridCol w="5213086"/>
-                <a:gridCol w="3882085"/>
+                <a:gridCol w="1996501">
+                  <a:extLst>
+                    <a:ext uri="{9D8B030D-6E8A-4147-A177-3AD203B41FA5}">
+                      <a16:colId xmlns:a16="http://schemas.microsoft.com/office/drawing/2014/main" val="20000"/>
+                    </a:ext>
+                  </a:extLst>
+                </a:gridCol>
+                <a:gridCol w="5213086">
+                  <a:extLst>
+                    <a:ext uri="{9D8B030D-6E8A-4147-A177-3AD203B41FA5}">
+                      <a16:colId xmlns:a16="http://schemas.microsoft.com/office/drawing/2014/main" val="20001"/>
+                    </a:ext>
+                  </a:extLst>
+                </a:gridCol>
+                <a:gridCol w="3882085">
+                  <a:extLst>
+                    <a:ext uri="{9D8B030D-6E8A-4147-A177-3AD203B41FA5}">
+                      <a16:colId xmlns:a16="http://schemas.microsoft.com/office/drawing/2014/main" val="20002"/>
+                    </a:ext>
+                  </a:extLst>
+                </a:gridCol>
               </a:tblGrid>
               <a:tr h="914400">
                 <a:tc>
@@ -9050,7 +9266,7 @@
                     <a:bodyPr/>
                     <a:lstStyle/>
                     <a:p>
-                      <a:pPr algn="ctr" indent="0" marL="0">
+                      <a:pPr marL="0" indent="0" algn="ctr">
                         <a:buNone/>
                       </a:pPr>
                       <a:r>
@@ -9118,7 +9334,7 @@
                     <a:bodyPr/>
                     <a:lstStyle/>
                     <a:p>
-                      <a:pPr algn="ctr" indent="0" marL="0">
+                      <a:pPr marL="0" indent="0" algn="ctr">
                         <a:buNone/>
                       </a:pPr>
                       <a:r>
@@ -9186,7 +9402,7 @@
                     <a:bodyPr/>
                     <a:lstStyle/>
                     <a:p>
-                      <a:pPr algn="ctr" indent="0" marL="0">
+                      <a:pPr marL="0" indent="0" algn="ctr">
                         <a:buNone/>
                       </a:pPr>
                       <a:r>
@@ -9249,6 +9465,11 @@
                     </a:solidFill>
                   </a:tcPr>
                 </a:tc>
+                <a:extLst>
+                  <a:ext uri="{0D108BD9-81ED-4DB2-BD59-A6C34878D82A}">
+                    <a16:rowId xmlns:a16="http://schemas.microsoft.com/office/drawing/2014/main" val="10000"/>
+                  </a:ext>
+                </a:extLst>
               </a:tr>
               <a:tr h="914400">
                 <a:tc>
@@ -9256,7 +9477,7 @@
                     <a:bodyPr/>
                     <a:lstStyle/>
                     <a:p>
-                      <a:pPr algn="l" indent="0" marL="0">
+                      <a:pPr marL="0" indent="0" algn="l">
                         <a:buNone/>
                       </a:pPr>
                       <a:r>
@@ -9324,7 +9545,7 @@
                     <a:bodyPr/>
                     <a:lstStyle/>
                     <a:p>
-                      <a:pPr algn="l" indent="0" marL="0">
+                      <a:pPr marL="0" indent="0" algn="l">
                         <a:buNone/>
                       </a:pPr>
                       <a:r>
@@ -9392,7 +9613,7 @@
                     <a:bodyPr/>
                     <a:lstStyle/>
                     <a:p>
-                      <a:pPr algn="l" indent="0" marL="0">
+                      <a:pPr marL="0" indent="0" algn="l">
                         <a:buNone/>
                       </a:pPr>
                       <a:r>
@@ -9455,6 +9676,11 @@
                     </a:solidFill>
                   </a:tcPr>
                 </a:tc>
+                <a:extLst>
+                  <a:ext uri="{0D108BD9-81ED-4DB2-BD59-A6C34878D82A}">
+                    <a16:rowId xmlns:a16="http://schemas.microsoft.com/office/drawing/2014/main" val="10001"/>
+                  </a:ext>
+                </a:extLst>
               </a:tr>
               <a:tr h="914400">
                 <a:tc>
@@ -9462,7 +9688,7 @@
                     <a:bodyPr/>
                     <a:lstStyle/>
                     <a:p>
-                      <a:pPr algn="l" indent="0" marL="0">
+                      <a:pPr marL="0" indent="0" algn="l">
                         <a:buNone/>
                       </a:pPr>
                       <a:r>
@@ -9530,7 +9756,7 @@
                     <a:bodyPr/>
                     <a:lstStyle/>
                     <a:p>
-                      <a:pPr algn="l" indent="0" marL="0">
+                      <a:pPr marL="0" indent="0" algn="l">
                         <a:buNone/>
                       </a:pPr>
                       <a:r>
@@ -9598,7 +9824,7 @@
                     <a:bodyPr/>
                     <a:lstStyle/>
                     <a:p>
-                      <a:pPr algn="l" indent="0" marL="0">
+                      <a:pPr marL="0" indent="0" algn="l">
                         <a:buNone/>
                       </a:pPr>
                       <a:r>
@@ -9661,6 +9887,11 @@
                     </a:solidFill>
                   </a:tcPr>
                 </a:tc>
+                <a:extLst>
+                  <a:ext uri="{0D108BD9-81ED-4DB2-BD59-A6C34878D82A}">
+                    <a16:rowId xmlns:a16="http://schemas.microsoft.com/office/drawing/2014/main" val="10002"/>
+                  </a:ext>
+                </a:extLst>
               </a:tr>
               <a:tr h="914400">
                 <a:tc>
@@ -9668,7 +9899,7 @@
                     <a:bodyPr/>
                     <a:lstStyle/>
                     <a:p>
-                      <a:pPr algn="l" indent="0" marL="0">
+                      <a:pPr marL="0" indent="0" algn="l">
                         <a:buNone/>
                       </a:pPr>
                       <a:r>
@@ -9736,7 +9967,7 @@
                     <a:bodyPr/>
                     <a:lstStyle/>
                     <a:p>
-                      <a:pPr algn="l" indent="0" marL="0">
+                      <a:pPr marL="0" indent="0" algn="l">
                         <a:buNone/>
                       </a:pPr>
                       <a:r>
@@ -9804,7 +10035,7 @@
                     <a:bodyPr/>
                     <a:lstStyle/>
                     <a:p>
-                      <a:pPr algn="l" indent="0" marL="0">
+                      <a:pPr marL="0" indent="0" algn="l">
                         <a:buNone/>
                       </a:pPr>
                       <a:r>
@@ -9867,6 +10098,11 @@
                     </a:solidFill>
                   </a:tcPr>
                 </a:tc>
+                <a:extLst>
+                  <a:ext uri="{0D108BD9-81ED-4DB2-BD59-A6C34878D82A}">
+                    <a16:rowId xmlns:a16="http://schemas.microsoft.com/office/drawing/2014/main" val="10003"/>
+                  </a:ext>
+                </a:extLst>
               </a:tr>
             </a:tbl>
           </a:graphicData>
@@ -9874,13 +10110,13 @@
       </p:graphicFrame>
       <p:sp>
         <p:nvSpPr>
-          <p:cNvPr id="5" name="Shape 2"/>
-          <p:cNvSpPr/>
-          <p:nvPr/>
-        </p:nvSpPr>
-        <p:spPr>
-          <a:xfrm>
-            <a:off x="548640" y="4480560"/>
+          <p:cNvPr id="4" name="Shape 2"/>
+          <p:cNvSpPr/>
+          <p:nvPr/>
+        </p:nvSpPr>
+        <p:spPr>
+          <a:xfrm>
+            <a:off x="548640" y="5276088"/>
             <a:ext cx="11091672" cy="868680"/>
           </a:xfrm>
           <a:prstGeom prst="roundRect">
@@ -9896,6 +10132,13 @@
             <a:prstDash val="solid"/>
           </a:ln>
         </p:spPr>
+        <p:txBody>
+          <a:bodyPr/>
+          <a:lstStyle/>
+          <a:p>
+            <a:endParaRPr lang="es-ES"/>
+          </a:p>
+        </p:txBody>
       </p:sp>
       <p:sp>
         <p:nvSpPr>
@@ -9905,7 +10148,7 @@
         </p:nvSpPr>
         <p:spPr>
           <a:xfrm>
-            <a:off x="777240" y="4553712"/>
+            <a:off x="777240" y="5299415"/>
             <a:ext cx="10634472" cy="722376"/>
           </a:xfrm>
           <a:prstGeom prst="rect">
@@ -9918,7 +10161,7 @@
           <a:bodyPr wrap="square" rtlCol="0" anchor="ctr"/>
           <a:lstStyle/>
           <a:p>
-            <a:pPr indent="0" marL="0">
+            <a:pPr marL="0" indent="0">
               <a:buNone/>
             </a:pPr>
             <a:r>
@@ -9957,7 +10200,7 @@
           <a:bodyPr wrap="square" rtlCol="0" anchor="ctr"/>
           <a:lstStyle/>
           <a:p>
-            <a:pPr algn="r" indent="0" marL="0">
+            <a:pPr marL="0" indent="0" algn="r">
               <a:buNone/>
             </a:pPr>
             <a:r>
@@ -10024,6 +10267,13 @@
             <a:prstDash val="solid"/>
           </a:ln>
         </p:spPr>
+        <p:txBody>
+          <a:bodyPr/>
+          <a:lstStyle/>
+          <a:p>
+            <a:endParaRPr lang="es-ES"/>
+          </a:p>
+        </p:txBody>
       </p:sp>
       <p:sp>
         <p:nvSpPr>
@@ -10046,7 +10296,7 @@
           <a:bodyPr wrap="square" rtlCol="0" anchor="ctr"/>
           <a:lstStyle/>
           <a:p>
-            <a:pPr indent="0" marL="0">
+            <a:pPr marL="0" indent="0">
               <a:buNone/>
             </a:pPr>
             <a:r>
@@ -10088,6 +10338,13 @@
             <a:prstDash val="solid"/>
           </a:ln>
         </p:spPr>
+        <p:txBody>
+          <a:bodyPr/>
+          <a:lstStyle/>
+          <a:p>
+            <a:endParaRPr lang="es-ES"/>
+          </a:p>
+        </p:txBody>
       </p:sp>
       <p:sp>
         <p:nvSpPr>
@@ -10110,7 +10367,7 @@
           <a:bodyPr wrap="square" rtlCol="0" anchor="ctr"/>
           <a:lstStyle/>
           <a:p>
-            <a:pPr indent="0" marL="0">
+            <a:pPr marL="0" indent="0">
               <a:buNone/>
             </a:pPr>
             <a:r>
@@ -10149,7 +10406,7 @@
           <a:bodyPr wrap="square" rtlCol="0" anchor="t"/>
           <a:lstStyle/>
           <a:p>
-            <a:pPr indent="0" marL="0">
+            <a:pPr marL="0" indent="0">
               <a:spcAft>
                 <a:spcPts val="800"/>
               </a:spcAft>
@@ -10191,25 +10448,32 @@
             <a:prstDash val="solid"/>
           </a:ln>
         </p:spPr>
+        <p:txBody>
+          <a:bodyPr/>
+          <a:lstStyle/>
+          <a:p>
+            <a:endParaRPr lang="es-ES"/>
+          </a:p>
+        </p:txBody>
       </p:sp>
       <p:pic>
         <p:nvPicPr>
-          <p:cNvPr id="8" name="Image 0" descr="C:/Users/Aitor/Documents/apuntes-profe/entornos-de-desarrollo/docs/tema6/img/secuencia-lifeline-paleta.png">    </p:cNvPr>
+          <p:cNvPr id="8" name="Image 0" descr="C:/Users/Aitor/Documents/apuntes-profe/entornos-de-desarrollo/docs/tema6/img/secuencia-lifeline-paleta.png"/>
           <p:cNvPicPr>
             <a:picLocks noChangeAspect="1"/>
           </p:cNvPicPr>
           <p:nvPr/>
         </p:nvPicPr>
         <p:blipFill>
-          <a:blip r:embed="rId1"/>
+          <a:blip r:embed="rId3"/>
           <a:stretch>
             <a:fillRect/>
           </a:stretch>
         </p:blipFill>
         <p:spPr>
           <a:xfrm>
-            <a:off x="2331720" y="2606040"/>
-            <a:ext cx="1554480" cy="1353312"/>
+            <a:off x="1846528" y="2313432"/>
+            <a:ext cx="3210664" cy="2795166"/>
           </a:xfrm>
           <a:prstGeom prst="rect">
             <a:avLst/>
@@ -10224,8 +10488,8 @@
         </p:nvSpPr>
         <p:spPr>
           <a:xfrm>
-            <a:off x="2057400" y="3986784"/>
-            <a:ext cx="2103120" cy="320040"/>
+            <a:off x="1768150" y="5464193"/>
+            <a:ext cx="3139751" cy="320040"/>
           </a:xfrm>
           <a:prstGeom prst="rect">
             <a:avLst/>
@@ -10237,11 +10501,11 @@
           <a:bodyPr wrap="square" rtlCol="0" anchor="t"/>
           <a:lstStyle/>
           <a:p>
-            <a:pPr algn="ctr" indent="0" marL="0">
+            <a:pPr marL="0" indent="0" algn="ctr">
               <a:buNone/>
             </a:pPr>
             <a:r>
-              <a:rPr lang="en-US" sz="1000" i="1" dirty="0">
+              <a:rPr lang="en-US" sz="1600" i="1" dirty="0">
                 <a:solidFill>
                   <a:srgbClr val="757575"/>
                 </a:solidFill>
@@ -10251,7 +10515,7 @@
               </a:rPr>
               <a:t>Icono de línea de vida (objeto) en la paleta UML de DIA</a:t>
             </a:r>
-            <a:endParaRPr lang="en-US" sz="1000" dirty="0"/>
+            <a:endParaRPr lang="en-US" sz="1600" dirty="0"/>
           </a:p>
         </p:txBody>
       </p:sp>
@@ -10279,6 +10543,13 @@
             <a:prstDash val="solid"/>
           </a:ln>
         </p:spPr>
+        <p:txBody>
+          <a:bodyPr/>
+          <a:lstStyle/>
+          <a:p>
+            <a:endParaRPr lang="es-ES"/>
+          </a:p>
+        </p:txBody>
       </p:sp>
       <p:sp>
         <p:nvSpPr>
@@ -10301,7 +10572,7 @@
           <a:bodyPr wrap="square" rtlCol="0" anchor="ctr"/>
           <a:lstStyle/>
           <a:p>
-            <a:pPr indent="0" marL="0">
+            <a:pPr marL="0" indent="0">
               <a:buNone/>
             </a:pPr>
             <a:r>
@@ -10340,7 +10611,7 @@
           <a:bodyPr wrap="square" rtlCol="0" anchor="t"/>
           <a:lstStyle/>
           <a:p>
-            <a:pPr indent="0" marL="0">
+            <a:pPr marL="0" indent="0">
               <a:spcAft>
                 <a:spcPts val="800"/>
               </a:spcAft>
@@ -10382,25 +10653,32 @@
             <a:prstDash val="solid"/>
           </a:ln>
         </p:spPr>
+        <p:txBody>
+          <a:bodyPr/>
+          <a:lstStyle/>
+          <a:p>
+            <a:endParaRPr lang="es-ES"/>
+          </a:p>
+        </p:txBody>
       </p:sp>
       <p:pic>
         <p:nvPicPr>
-          <p:cNvPr id="14" name="Image 1" descr="C:/Users/Aitor/Documents/apuntes-profe/entornos-de-desarrollo/docs/tema6/img/secuencia-activacion-canvas.png">    </p:cNvPr>
+          <p:cNvPr id="14" name="Image 1" descr="C:/Users/Aitor/Documents/apuntes-profe/entornos-de-desarrollo/docs/tema6/img/secuencia-activacion-canvas.png"/>
           <p:cNvPicPr>
             <a:picLocks noChangeAspect="1"/>
           </p:cNvPicPr>
           <p:nvPr/>
         </p:nvPicPr>
         <p:blipFill>
-          <a:blip r:embed="rId2"/>
+          <a:blip r:embed="rId4"/>
           <a:stretch>
             <a:fillRect/>
           </a:stretch>
         </p:blipFill>
         <p:spPr>
           <a:xfrm>
-            <a:off x="8412480" y="2606040"/>
-            <a:ext cx="1737360" cy="1335024"/>
+            <a:off x="7204210" y="2261180"/>
+            <a:ext cx="3513820" cy="2700093"/>
           </a:xfrm>
           <a:prstGeom prst="rect">
             <a:avLst/>
@@ -10415,8 +10693,8 @@
         </p:nvSpPr>
         <p:spPr>
           <a:xfrm>
-            <a:off x="8138160" y="3968496"/>
-            <a:ext cx="2286000" cy="320040"/>
+            <a:off x="7775199" y="5306133"/>
+            <a:ext cx="3011922" cy="822959"/>
           </a:xfrm>
           <a:prstGeom prst="rect">
             <a:avLst/>
@@ -10428,11 +10706,11 @@
           <a:bodyPr wrap="square" rtlCol="0" anchor="t"/>
           <a:lstStyle/>
           <a:p>
-            <a:pPr algn="ctr" indent="0" marL="0">
+            <a:pPr marL="0" indent="0" algn="ctr">
               <a:buNone/>
             </a:pPr>
             <a:r>
-              <a:rPr lang="en-US" sz="1000" i="1" dirty="0">
+              <a:rPr lang="en-US" sz="1600" i="1" dirty="0">
                 <a:solidFill>
                   <a:srgbClr val="757575"/>
                 </a:solidFill>
@@ -10442,7 +10720,7 @@
               </a:rPr>
               <a:t>Barra de activación sobre la línea de vida en DIA</a:t>
             </a:r>
-            <a:endParaRPr lang="en-US" sz="1000" dirty="0"/>
+            <a:endParaRPr lang="en-US" sz="1600" dirty="0"/>
           </a:p>
         </p:txBody>
       </p:sp>
@@ -10467,7 +10745,7 @@
           <a:bodyPr wrap="square" rtlCol="0" anchor="ctr"/>
           <a:lstStyle/>
           <a:p>
-            <a:pPr algn="r" indent="0" marL="0">
+            <a:pPr marL="0" indent="0" algn="r">
               <a:buNone/>
             </a:pPr>
             <a:r>
@@ -10534,6 +10812,13 @@
             <a:prstDash val="solid"/>
           </a:ln>
         </p:spPr>
+        <p:txBody>
+          <a:bodyPr/>
+          <a:lstStyle/>
+          <a:p>
+            <a:endParaRPr lang="es-ES"/>
+          </a:p>
+        </p:txBody>
       </p:sp>
       <p:sp>
         <p:nvSpPr>
@@ -10556,7 +10841,7 @@
           <a:bodyPr wrap="square" rtlCol="0" anchor="ctr"/>
           <a:lstStyle/>
           <a:p>
-            <a:pPr indent="0" marL="0">
+            <a:pPr marL="0" indent="0">
               <a:buNone/>
             </a:pPr>
             <a:r>
@@ -10595,7 +10880,7 @@
           <a:bodyPr wrap="square" rtlCol="0" anchor="t"/>
           <a:lstStyle/>
           <a:p>
-            <a:pPr indent="0" marL="0">
+            <a:pPr marL="0" indent="0">
               <a:spcAft>
                 <a:spcPts val="1000"/>
               </a:spcAft>
@@ -10615,7 +10900,7 @@
             <a:endParaRPr lang="en-US" sz="1600" dirty="0"/>
           </a:p>
           <a:p>
-            <a:pPr indent="0" marL="0">
+            <a:pPr marL="0" indent="0">
               <a:spcAft>
                 <a:spcPts val="1000"/>
               </a:spcAft>
@@ -10657,17 +10942,24 @@
             <a:prstDash val="solid"/>
           </a:ln>
         </p:spPr>
+        <p:txBody>
+          <a:bodyPr/>
+          <a:lstStyle/>
+          <a:p>
+            <a:endParaRPr lang="es-ES"/>
+          </a:p>
+        </p:txBody>
       </p:sp>
       <p:pic>
         <p:nvPicPr>
-          <p:cNvPr id="6" name="Image 0" descr="C:/Users/Aitor/Documents/apuntes-profe/entornos-de-desarrollo/docs/tema6/img/dia-lifeline-foco-no.png">    </p:cNvPr>
+          <p:cNvPr id="6" name="Image 0" descr="C:/Users/Aitor/Documents/apuntes-profe/entornos-de-desarrollo/docs/tema6/img/dia-lifeline-foco-no.png"/>
           <p:cNvPicPr>
             <a:picLocks noChangeAspect="1"/>
           </p:cNvPicPr>
           <p:nvPr/>
         </p:nvPicPr>
         <p:blipFill>
-          <a:blip r:embed="rId1"/>
+          <a:blip r:embed="rId3"/>
           <a:stretch>
             <a:fillRect/>
           </a:stretch>
@@ -10703,7 +10995,7 @@
           <a:bodyPr wrap="square" rtlCol="0" anchor="t"/>
           <a:lstStyle/>
           <a:p>
-            <a:pPr algn="ctr" indent="0" marL="0">
+            <a:pPr marL="0" indent="0" algn="ctr">
               <a:buNone/>
             </a:pPr>
             <a:r>
@@ -10742,17 +11034,24 @@
             <a:prstDash val="solid"/>
           </a:ln>
         </p:spPr>
+        <p:txBody>
+          <a:bodyPr/>
+          <a:lstStyle/>
+          <a:p>
+            <a:endParaRPr lang="es-ES"/>
+          </a:p>
+        </p:txBody>
       </p:sp>
       <p:pic>
         <p:nvPicPr>
-          <p:cNvPr id="9" name="Image 1" descr="C:/Users/Aitor/Documents/apuntes-profe/entornos-de-desarrollo/docs/tema6/img/dia-lifeline-reducir-distancia.png">    </p:cNvPr>
+          <p:cNvPr id="9" name="Image 1" descr="C:/Users/Aitor/Documents/apuntes-profe/entornos-de-desarrollo/docs/tema6/img/dia-lifeline-reducir-distancia.png"/>
           <p:cNvPicPr>
             <a:picLocks noChangeAspect="1"/>
           </p:cNvPicPr>
           <p:nvPr/>
         </p:nvPicPr>
         <p:blipFill>
-          <a:blip r:embed="rId2"/>
+          <a:blip r:embed="rId4"/>
           <a:stretch>
             <a:fillRect/>
           </a:stretch>
@@ -10788,7 +11087,7 @@
           <a:bodyPr wrap="square" rtlCol="0" anchor="t"/>
           <a:lstStyle/>
           <a:p>
-            <a:pPr algn="ctr" indent="0" marL="0">
+            <a:pPr marL="0" indent="0" algn="ctr">
               <a:buNone/>
             </a:pPr>
             <a:r>
@@ -10827,7 +11126,7 @@
           <a:bodyPr wrap="square" rtlCol="0" anchor="ctr"/>
           <a:lstStyle/>
           <a:p>
-            <a:pPr algn="r" indent="0" marL="0">
+            <a:pPr marL="0" indent="0" algn="r">
               <a:buNone/>
             </a:pPr>
             <a:r>
@@ -10894,6 +11193,13 @@
             <a:prstDash val="solid"/>
           </a:ln>
         </p:spPr>
+        <p:txBody>
+          <a:bodyPr/>
+          <a:lstStyle/>
+          <a:p>
+            <a:endParaRPr lang="es-ES"/>
+          </a:p>
+        </p:txBody>
       </p:sp>
       <p:sp>
         <p:nvSpPr>
@@ -10916,7 +11222,7 @@
           <a:bodyPr wrap="square" rtlCol="0" anchor="ctr"/>
           <a:lstStyle/>
           <a:p>
-            <a:pPr indent="0" marL="0">
+            <a:pPr marL="0" indent="0">
               <a:buNone/>
             </a:pPr>
             <a:r>
@@ -10950,16 +11256,34 @@
         </p:nvGraphicFramePr>
         <p:xfrm>
           <a:off x="548640" y="1051560"/>
-          <a:ext cx="11091672" cy="914400"/>
+          <a:ext cx="11091672" cy="3968496"/>
         </p:xfrm>
         <a:graphic>
           <a:graphicData uri="http://schemas.openxmlformats.org/drawingml/2006/table">
             <a:tbl>
               <a:tblPr/>
               <a:tblGrid>
-                <a:gridCol w="2218334"/>
-                <a:gridCol w="1774668"/>
-                <a:gridCol w="7098670"/>
+                <a:gridCol w="2218334">
+                  <a:extLst>
+                    <a:ext uri="{9D8B030D-6E8A-4147-A177-3AD203B41FA5}">
+                      <a16:colId xmlns:a16="http://schemas.microsoft.com/office/drawing/2014/main" val="20000"/>
+                    </a:ext>
+                  </a:extLst>
+                </a:gridCol>
+                <a:gridCol w="1774668">
+                  <a:extLst>
+                    <a:ext uri="{9D8B030D-6E8A-4147-A177-3AD203B41FA5}">
+                      <a16:colId xmlns:a16="http://schemas.microsoft.com/office/drawing/2014/main" val="20001"/>
+                    </a:ext>
+                  </a:extLst>
+                </a:gridCol>
+                <a:gridCol w="7098670">
+                  <a:extLst>
+                    <a:ext uri="{9D8B030D-6E8A-4147-A177-3AD203B41FA5}">
+                      <a16:colId xmlns:a16="http://schemas.microsoft.com/office/drawing/2014/main" val="20002"/>
+                    </a:ext>
+                  </a:extLst>
+                </a:gridCol>
               </a:tblGrid>
               <a:tr h="566928">
                 <a:tc>
@@ -10967,7 +11291,7 @@
                     <a:bodyPr/>
                     <a:lstStyle/>
                     <a:p>
-                      <a:pPr algn="ctr" indent="0" marL="0">
+                      <a:pPr marL="0" indent="0" algn="ctr">
                         <a:buNone/>
                       </a:pPr>
                       <a:r>
@@ -11035,7 +11359,7 @@
                     <a:bodyPr/>
                     <a:lstStyle/>
                     <a:p>
-                      <a:pPr algn="ctr" indent="0" marL="0">
+                      <a:pPr marL="0" indent="0" algn="ctr">
                         <a:buNone/>
                       </a:pPr>
                       <a:r>
@@ -11103,7 +11427,7 @@
                     <a:bodyPr/>
                     <a:lstStyle/>
                     <a:p>
-                      <a:pPr algn="ctr" indent="0" marL="0">
+                      <a:pPr marL="0" indent="0" algn="ctr">
                         <a:buNone/>
                       </a:pPr>
                       <a:r>
@@ -11166,6 +11490,11 @@
                     </a:solidFill>
                   </a:tcPr>
                 </a:tc>
+                <a:extLst>
+                  <a:ext uri="{0D108BD9-81ED-4DB2-BD59-A6C34878D82A}">
+                    <a16:rowId xmlns:a16="http://schemas.microsoft.com/office/drawing/2014/main" val="10000"/>
+                  </a:ext>
+                </a:extLst>
               </a:tr>
               <a:tr h="566928">
                 <a:tc>
@@ -11173,7 +11502,7 @@
                     <a:bodyPr/>
                     <a:lstStyle/>
                     <a:p>
-                      <a:pPr algn="l" indent="0" marL="0">
+                      <a:pPr marL="0" indent="0" algn="l">
                         <a:buNone/>
                       </a:pPr>
                       <a:r>
@@ -11241,7 +11570,7 @@
                     <a:bodyPr/>
                     <a:lstStyle/>
                     <a:p>
-                      <a:pPr algn="l" indent="0" marL="0">
+                      <a:pPr marL="0" indent="0" algn="l">
                         <a:buNone/>
                       </a:pPr>
                       <a:r>
@@ -11309,7 +11638,7 @@
                     <a:bodyPr/>
                     <a:lstStyle/>
                     <a:p>
-                      <a:pPr algn="l" indent="0" marL="0">
+                      <a:pPr marL="0" indent="0" algn="l">
                         <a:buNone/>
                       </a:pPr>
                       <a:r>
@@ -11372,6 +11701,11 @@
                     </a:solidFill>
                   </a:tcPr>
                 </a:tc>
+                <a:extLst>
+                  <a:ext uri="{0D108BD9-81ED-4DB2-BD59-A6C34878D82A}">
+                    <a16:rowId xmlns:a16="http://schemas.microsoft.com/office/drawing/2014/main" val="10001"/>
+                  </a:ext>
+                </a:extLst>
               </a:tr>
               <a:tr h="566928">
                 <a:tc>
@@ -11379,7 +11713,7 @@
                     <a:bodyPr/>
                     <a:lstStyle/>
                     <a:p>
-                      <a:pPr algn="l" indent="0" marL="0">
+                      <a:pPr marL="0" indent="0" algn="l">
                         <a:buNone/>
                       </a:pPr>
                       <a:r>
@@ -11447,7 +11781,7 @@
                     <a:bodyPr/>
                     <a:lstStyle/>
                     <a:p>
-                      <a:pPr algn="l" indent="0" marL="0">
+                      <a:pPr marL="0" indent="0" algn="l">
                         <a:buNone/>
                       </a:pPr>
                       <a:r>
@@ -11515,7 +11849,7 @@
                     <a:bodyPr/>
                     <a:lstStyle/>
                     <a:p>
-                      <a:pPr algn="l" indent="0" marL="0">
+                      <a:pPr marL="0" indent="0" algn="l">
                         <a:buNone/>
                       </a:pPr>
                       <a:r>
@@ -11578,6 +11912,11 @@
                     </a:solidFill>
                   </a:tcPr>
                 </a:tc>
+                <a:extLst>
+                  <a:ext uri="{0D108BD9-81ED-4DB2-BD59-A6C34878D82A}">
+                    <a16:rowId xmlns:a16="http://schemas.microsoft.com/office/drawing/2014/main" val="10002"/>
+                  </a:ext>
+                </a:extLst>
               </a:tr>
               <a:tr h="566928">
                 <a:tc>
@@ -11585,7 +11924,7 @@
                     <a:bodyPr/>
                     <a:lstStyle/>
                     <a:p>
-                      <a:pPr algn="l" indent="0" marL="0">
+                      <a:pPr marL="0" indent="0" algn="l">
                         <a:buNone/>
                       </a:pPr>
                       <a:r>
@@ -11653,7 +11992,7 @@
                     <a:bodyPr/>
                     <a:lstStyle/>
                     <a:p>
-                      <a:pPr algn="l" indent="0" marL="0">
+                      <a:pPr marL="0" indent="0" algn="l">
                         <a:buNone/>
                       </a:pPr>
                       <a:r>
@@ -11721,7 +12060,7 @@
                     <a:bodyPr/>
                     <a:lstStyle/>
                     <a:p>
-                      <a:pPr algn="l" indent="0" marL="0">
+                      <a:pPr marL="0" indent="0" algn="l">
                         <a:buNone/>
                       </a:pPr>
                       <a:r>
@@ -11784,6 +12123,11 @@
                     </a:solidFill>
                   </a:tcPr>
                 </a:tc>
+                <a:extLst>
+                  <a:ext uri="{0D108BD9-81ED-4DB2-BD59-A6C34878D82A}">
+                    <a16:rowId xmlns:a16="http://schemas.microsoft.com/office/drawing/2014/main" val="10003"/>
+                  </a:ext>
+                </a:extLst>
               </a:tr>
               <a:tr h="566928">
                 <a:tc>
@@ -11791,7 +12135,7 @@
                     <a:bodyPr/>
                     <a:lstStyle/>
                     <a:p>
-                      <a:pPr algn="l" indent="0" marL="0">
+                      <a:pPr marL="0" indent="0" algn="l">
                         <a:buNone/>
                       </a:pPr>
                       <a:r>
@@ -11859,7 +12203,7 @@
                     <a:bodyPr/>
                     <a:lstStyle/>
                     <a:p>
-                      <a:pPr algn="l" indent="0" marL="0">
+                      <a:pPr marL="0" indent="0" algn="l">
                         <a:buNone/>
                       </a:pPr>
                       <a:r>
@@ -11927,7 +12271,7 @@
                     <a:bodyPr/>
                     <a:lstStyle/>
                     <a:p>
-                      <a:pPr algn="l" indent="0" marL="0">
+                      <a:pPr marL="0" indent="0" algn="l">
                         <a:buNone/>
                       </a:pPr>
                       <a:r>
@@ -11990,6 +12334,11 @@
                     </a:solidFill>
                   </a:tcPr>
                 </a:tc>
+                <a:extLst>
+                  <a:ext uri="{0D108BD9-81ED-4DB2-BD59-A6C34878D82A}">
+                    <a16:rowId xmlns:a16="http://schemas.microsoft.com/office/drawing/2014/main" val="10004"/>
+                  </a:ext>
+                </a:extLst>
               </a:tr>
               <a:tr h="566928">
                 <a:tc>
@@ -11997,7 +12346,7 @@
                     <a:bodyPr/>
                     <a:lstStyle/>
                     <a:p>
-                      <a:pPr algn="l" indent="0" marL="0">
+                      <a:pPr marL="0" indent="0" algn="l">
                         <a:buNone/>
                       </a:pPr>
                       <a:r>
@@ -12065,7 +12414,7 @@
                     <a:bodyPr/>
                     <a:lstStyle/>
                     <a:p>
-                      <a:pPr algn="l" indent="0" marL="0">
+                      <a:pPr marL="0" indent="0" algn="l">
                         <a:buNone/>
                       </a:pPr>
                       <a:r>
@@ -12133,7 +12482,7 @@
                     <a:bodyPr/>
                     <a:lstStyle/>
                     <a:p>
-                      <a:pPr algn="l" indent="0" marL="0">
+                      <a:pPr marL="0" indent="0" algn="l">
                         <a:buNone/>
                       </a:pPr>
                       <a:r>
@@ -12196,6 +12545,11 @@
                     </a:solidFill>
                   </a:tcPr>
                 </a:tc>
+                <a:extLst>
+                  <a:ext uri="{0D108BD9-81ED-4DB2-BD59-A6C34878D82A}">
+                    <a16:rowId xmlns:a16="http://schemas.microsoft.com/office/drawing/2014/main" val="10005"/>
+                  </a:ext>
+                </a:extLst>
               </a:tr>
               <a:tr h="566928">
                 <a:tc>
@@ -12203,7 +12557,7 @@
                     <a:bodyPr/>
                     <a:lstStyle/>
                     <a:p>
-                      <a:pPr algn="l" indent="0" marL="0">
+                      <a:pPr marL="0" indent="0" algn="l">
                         <a:buNone/>
                       </a:pPr>
                       <a:r>
@@ -12271,7 +12625,7 @@
                     <a:bodyPr/>
                     <a:lstStyle/>
                     <a:p>
-                      <a:pPr algn="l" indent="0" marL="0">
+                      <a:pPr marL="0" indent="0" algn="l">
                         <a:buNone/>
                       </a:pPr>
                       <a:r>
@@ -12339,7 +12693,7 @@
                     <a:bodyPr/>
                     <a:lstStyle/>
                     <a:p>
-                      <a:pPr algn="l" indent="0" marL="0">
+                      <a:pPr marL="0" indent="0" algn="l">
                         <a:buNone/>
                       </a:pPr>
                       <a:r>
@@ -12402,6 +12756,11 @@
                     </a:solidFill>
                   </a:tcPr>
                 </a:tc>
+                <a:extLst>
+                  <a:ext uri="{0D108BD9-81ED-4DB2-BD59-A6C34878D82A}">
+                    <a16:rowId xmlns:a16="http://schemas.microsoft.com/office/drawing/2014/main" val="10006"/>
+                  </a:ext>
+                </a:extLst>
               </a:tr>
             </a:tbl>
           </a:graphicData>
@@ -12431,6 +12790,13 @@
             <a:prstDash val="solid"/>
           </a:ln>
         </p:spPr>
+        <p:txBody>
+          <a:bodyPr/>
+          <a:lstStyle/>
+          <a:p>
+            <a:endParaRPr lang="es-ES"/>
+          </a:p>
+        </p:txBody>
       </p:sp>
       <p:sp>
         <p:nvSpPr>
@@ -12453,7 +12819,7 @@
           <a:bodyPr wrap="square" rtlCol="0" anchor="ctr"/>
           <a:lstStyle/>
           <a:p>
-            <a:pPr indent="0" marL="0">
+            <a:pPr marL="0" indent="0">
               <a:buNone/>
             </a:pPr>
             <a:r>
@@ -12492,7 +12858,7 @@
           <a:bodyPr wrap="square" rtlCol="0" anchor="ctr"/>
           <a:lstStyle/>
           <a:p>
-            <a:pPr algn="r" indent="0" marL="0">
+            <a:pPr marL="0" indent="0" algn="r">
               <a:buNone/>
             </a:pPr>
             <a:r>
@@ -12559,6 +12925,13 @@
             <a:prstDash val="solid"/>
           </a:ln>
         </p:spPr>
+        <p:txBody>
+          <a:bodyPr/>
+          <a:lstStyle/>
+          <a:p>
+            <a:endParaRPr lang="es-ES"/>
+          </a:p>
+        </p:txBody>
       </p:sp>
       <p:sp>
         <p:nvSpPr>
@@ -12581,7 +12954,7 @@
           <a:bodyPr wrap="square" rtlCol="0" anchor="ctr"/>
           <a:lstStyle/>
           <a:p>
-            <a:pPr indent="0" marL="0">
+            <a:pPr marL="0" indent="0">
               <a:buNone/>
             </a:pPr>
             <a:r>
@@ -12620,7 +12993,7 @@
           <a:bodyPr wrap="square" rtlCol="0" anchor="t"/>
           <a:lstStyle/>
           <a:p>
-            <a:pPr indent="0" marL="0">
+            <a:pPr marL="0" indent="0">
               <a:spcAft>
                 <a:spcPts val="800"/>
               </a:spcAft>
@@ -12662,17 +13035,24 @@
             <a:prstDash val="solid"/>
           </a:ln>
         </p:spPr>
+        <p:txBody>
+          <a:bodyPr/>
+          <a:lstStyle/>
+          <a:p>
+            <a:endParaRPr lang="es-ES"/>
+          </a:p>
+        </p:txBody>
       </p:sp>
       <p:pic>
         <p:nvPicPr>
-          <p:cNvPr id="6" name="Image 0" descr="C:/Users/Aitor/Documents/apuntes-profe/entornos-de-desarrollo/docs/tema6/img/secuencia-mensaje-llamada.png">    </p:cNvPr>
+          <p:cNvPr id="6" name="Image 0" descr="C:/Users/Aitor/Documents/apuntes-profe/entornos-de-desarrollo/docs/tema6/img/secuencia-mensaje-llamada.png"/>
           <p:cNvPicPr>
             <a:picLocks noChangeAspect="1"/>
           </p:cNvPicPr>
           <p:nvPr/>
         </p:nvPicPr>
         <p:blipFill>
-          <a:blip r:embed="rId1"/>
+          <a:blip r:embed="rId3"/>
           <a:stretch>
             <a:fillRect/>
           </a:stretch>
@@ -12708,7 +13088,7 @@
           <a:bodyPr wrap="square" rtlCol="0" anchor="t"/>
           <a:lstStyle/>
           <a:p>
-            <a:pPr algn="ctr" indent="0" marL="0">
+            <a:pPr marL="0" indent="0" algn="ctr">
               <a:buNone/>
             </a:pPr>
             <a:r>
@@ -12747,17 +13127,24 @@
             <a:prstDash val="solid"/>
           </a:ln>
         </p:spPr>
+        <p:txBody>
+          <a:bodyPr/>
+          <a:lstStyle/>
+          <a:p>
+            <a:endParaRPr lang="es-ES"/>
+          </a:p>
+        </p:txBody>
       </p:sp>
       <p:pic>
         <p:nvPicPr>
-          <p:cNvPr id="9" name="Image 1" descr="C:/Users/Aitor/Documents/apuntes-profe/entornos-de-desarrollo/docs/tema6/img/secuencia-mensaje-simple.png">    </p:cNvPr>
+          <p:cNvPr id="9" name="Image 1" descr="C:/Users/Aitor/Documents/apuntes-profe/entornos-de-desarrollo/docs/tema6/img/secuencia-mensaje-simple.png"/>
           <p:cNvPicPr>
             <a:picLocks noChangeAspect="1"/>
           </p:cNvPicPr>
           <p:nvPr/>
         </p:nvPicPr>
         <p:blipFill>
-          <a:blip r:embed="rId2"/>
+          <a:blip r:embed="rId4"/>
           <a:stretch>
             <a:fillRect/>
           </a:stretch>
@@ -12793,7 +13180,7 @@
           <a:bodyPr wrap="square" rtlCol="0" anchor="t"/>
           <a:lstStyle/>
           <a:p>
-            <a:pPr algn="ctr" indent="0" marL="0">
+            <a:pPr marL="0" indent="0" algn="ctr">
               <a:buNone/>
             </a:pPr>
             <a:r>
@@ -12832,17 +13219,24 @@
             <a:prstDash val="solid"/>
           </a:ln>
         </p:spPr>
+        <p:txBody>
+          <a:bodyPr/>
+          <a:lstStyle/>
+          <a:p>
+            <a:endParaRPr lang="es-ES"/>
+          </a:p>
+        </p:txBody>
       </p:sp>
       <p:pic>
         <p:nvPicPr>
-          <p:cNvPr id="12" name="Image 2" descr="C:/Users/Aitor/Documents/apuntes-profe/entornos-de-desarrollo/docs/tema6/img/secuencia-mensaje-volver.png">    </p:cNvPr>
+          <p:cNvPr id="12" name="Image 2" descr="C:/Users/Aitor/Documents/apuntes-profe/entornos-de-desarrollo/docs/tema6/img/secuencia-mensaje-volver.png"/>
           <p:cNvPicPr>
             <a:picLocks noChangeAspect="1"/>
           </p:cNvPicPr>
           <p:nvPr/>
         </p:nvPicPr>
         <p:blipFill>
-          <a:blip r:embed="rId3"/>
+          <a:blip r:embed="rId5"/>
           <a:stretch>
             <a:fillRect/>
           </a:stretch>
@@ -12878,7 +13272,7 @@
           <a:bodyPr wrap="square" rtlCol="0" anchor="t"/>
           <a:lstStyle/>
           <a:p>
-            <a:pPr algn="ctr" indent="0" marL="0">
+            <a:pPr marL="0" indent="0" algn="ctr">
               <a:buNone/>
             </a:pPr>
             <a:r>
@@ -12917,7 +13311,7 @@
           <a:bodyPr wrap="square" rtlCol="0" anchor="ctr"/>
           <a:lstStyle/>
           <a:p>
-            <a:pPr algn="r" indent="0" marL="0">
+            <a:pPr marL="0" indent="0" algn="r">
               <a:buNone/>
             </a:pPr>
             <a:r>
@@ -12984,6 +13378,13 @@
             <a:prstDash val="solid"/>
           </a:ln>
         </p:spPr>
+        <p:txBody>
+          <a:bodyPr/>
+          <a:lstStyle/>
+          <a:p>
+            <a:endParaRPr lang="es-ES"/>
+          </a:p>
+        </p:txBody>
       </p:sp>
       <p:sp>
         <p:nvSpPr>
@@ -13006,7 +13407,7 @@
           <a:bodyPr wrap="square" rtlCol="0" anchor="ctr"/>
           <a:lstStyle/>
           <a:p>
-            <a:pPr indent="0" marL="0">
+            <a:pPr marL="0" indent="0">
               <a:buNone/>
             </a:pPr>
             <a:r>
@@ -13045,7 +13446,7 @@
           <a:bodyPr wrap="square" rtlCol="0" anchor="t"/>
           <a:lstStyle/>
           <a:p>
-            <a:pPr indent="0" marL="0">
+            <a:pPr marL="0" indent="0">
               <a:spcAft>
                 <a:spcPts val="800"/>
               </a:spcAft>
@@ -13087,17 +13488,24 @@
             <a:prstDash val="solid"/>
           </a:ln>
         </p:spPr>
+        <p:txBody>
+          <a:bodyPr/>
+          <a:lstStyle/>
+          <a:p>
+            <a:endParaRPr lang="es-ES"/>
+          </a:p>
+        </p:txBody>
       </p:sp>
       <p:pic>
         <p:nvPicPr>
-          <p:cNvPr id="6" name="Image 0" descr="C:/Users/Aitor/Documents/apuntes-profe/entornos-de-desarrollo/docs/tema6/img/secuencia-mensaje-crear.png">    </p:cNvPr>
+          <p:cNvPr id="6" name="Image 0" descr="C:/Users/Aitor/Documents/apuntes-profe/entornos-de-desarrollo/docs/tema6/img/secuencia-mensaje-crear.png"/>
           <p:cNvPicPr>
             <a:picLocks noChangeAspect="1"/>
           </p:cNvPicPr>
           <p:nvPr/>
         </p:nvPicPr>
         <p:blipFill>
-          <a:blip r:embed="rId1"/>
+          <a:blip r:embed="rId3"/>
           <a:stretch>
             <a:fillRect/>
           </a:stretch>
@@ -13133,7 +13541,7 @@
           <a:bodyPr wrap="square" rtlCol="0" anchor="t"/>
           <a:lstStyle/>
           <a:p>
-            <a:pPr algn="ctr" indent="0" marL="0">
+            <a:pPr marL="0" indent="0" algn="ctr">
               <a:buNone/>
             </a:pPr>
             <a:r>
@@ -13172,17 +13580,24 @@
             <a:prstDash val="solid"/>
           </a:ln>
         </p:spPr>
+        <p:txBody>
+          <a:bodyPr/>
+          <a:lstStyle/>
+          <a:p>
+            <a:endParaRPr lang="es-ES"/>
+          </a:p>
+        </p:txBody>
       </p:sp>
       <p:pic>
         <p:nvPicPr>
-          <p:cNvPr id="9" name="Image 1" descr="C:/Users/Aitor/Documents/apuntes-profe/entornos-de-desarrollo/docs/tema6/img/secuencia-mensaje-recursiva.png">    </p:cNvPr>
+          <p:cNvPr id="9" name="Image 1" descr="C:/Users/Aitor/Documents/apuntes-profe/entornos-de-desarrollo/docs/tema6/img/secuencia-mensaje-recursiva.png"/>
           <p:cNvPicPr>
             <a:picLocks noChangeAspect="1"/>
           </p:cNvPicPr>
           <p:nvPr/>
         </p:nvPicPr>
         <p:blipFill>
-          <a:blip r:embed="rId2"/>
+          <a:blip r:embed="rId4"/>
           <a:stretch>
             <a:fillRect/>
           </a:stretch>
@@ -13218,7 +13633,7 @@
           <a:bodyPr wrap="square" rtlCol="0" anchor="t"/>
           <a:lstStyle/>
           <a:p>
-            <a:pPr algn="ctr" indent="0" marL="0">
+            <a:pPr marL="0" indent="0" algn="ctr">
               <a:buNone/>
             </a:pPr>
             <a:r>
@@ -13257,7 +13672,7 @@
           <a:bodyPr wrap="square" rtlCol="0" anchor="ctr"/>
           <a:lstStyle/>
           <a:p>
-            <a:pPr algn="r" indent="0" marL="0">
+            <a:pPr marL="0" indent="0" algn="r">
               <a:buNone/>
             </a:pPr>
             <a:r>
@@ -13576,4 +13991,319 @@
     </a:ext>
   </a:extLst>
 </a:theme>
+</file>
+
+<file path=ppt/theme/theme2.xml><?xml version="1.0" encoding="utf-8"?>
+<a:theme xmlns:a="http://schemas.openxmlformats.org/drawingml/2006/main" name="Tema de Office">
+  <a:themeElements>
+    <a:clrScheme name="Office">
+      <a:dk1>
+        <a:sysClr val="windowText" lastClr="000000"/>
+      </a:dk1>
+      <a:lt1>
+        <a:sysClr val="window" lastClr="FFFFFF"/>
+      </a:lt1>
+      <a:dk2>
+        <a:srgbClr val="0E2841"/>
+      </a:dk2>
+      <a:lt2>
+        <a:srgbClr val="E8E8E8"/>
+      </a:lt2>
+      <a:accent1>
+        <a:srgbClr val="156082"/>
+      </a:accent1>
+      <a:accent2>
+        <a:srgbClr val="E97132"/>
+      </a:accent2>
+      <a:accent3>
+        <a:srgbClr val="196B24"/>
+      </a:accent3>
+      <a:accent4>
+        <a:srgbClr val="0F9ED5"/>
+      </a:accent4>
+      <a:accent5>
+        <a:srgbClr val="A02B93"/>
+      </a:accent5>
+      <a:accent6>
+        <a:srgbClr val="4EA72E"/>
+      </a:accent6>
+      <a:hlink>
+        <a:srgbClr val="467886"/>
+      </a:hlink>
+      <a:folHlink>
+        <a:srgbClr val="96607D"/>
+      </a:folHlink>
+    </a:clrScheme>
+    <a:fontScheme name="Office">
+      <a:majorFont>
+        <a:latin typeface="Aptos Display" panose="02110004020202020204"/>
+        <a:ea typeface=""/>
+        <a:cs typeface=""/>
+        <a:font script="Jpan" typeface="游ゴシック Light"/>
+        <a:font script="Hang" typeface="맑은 고딕"/>
+        <a:font script="Hans" typeface="等线 Light"/>
+        <a:font script="Hant" typeface="新細明體"/>
+        <a:font script="Arab" typeface="Times New Roman"/>
+        <a:font script="Hebr" typeface="Times New Roman"/>
+        <a:font script="Thai" typeface="Angsana New"/>
+        <a:font script="Ethi" typeface="Nyala"/>
+        <a:font script="Beng" typeface="Vrinda"/>
+        <a:font script="Gujr" typeface="Shruti"/>
+        <a:font script="Khmr" typeface="MoolBoran"/>
+        <a:font script="Knda" typeface="Tunga"/>
+        <a:font script="Guru" typeface="Raavi"/>
+        <a:font script="Cans" typeface="Euphemia"/>
+        <a:font script="Cher" typeface="Plantagenet Cherokee"/>
+        <a:font script="Yiii" typeface="Microsoft Yi Baiti"/>
+        <a:font script="Tibt" typeface="Microsoft Himalaya"/>
+        <a:font script="Thaa" typeface="MV Boli"/>
+        <a:font script="Deva" typeface="Mangal"/>
+        <a:font script="Telu" typeface="Gautami"/>
+        <a:font script="Taml" typeface="Latha"/>
+        <a:font script="Syrc" typeface="Estrangelo Edessa"/>
+        <a:font script="Orya" typeface="Kalinga"/>
+        <a:font script="Mlym" typeface="Kartika"/>
+        <a:font script="Laoo" typeface="DokChampa"/>
+        <a:font script="Sinh" typeface="Iskoola Pota"/>
+        <a:font script="Mong" typeface="Mongolian Baiti"/>
+        <a:font script="Viet" typeface="Times New Roman"/>
+        <a:font script="Uigh" typeface="Microsoft Uighur"/>
+        <a:font script="Geor" typeface="Sylfaen"/>
+        <a:font script="Armn" typeface="Arial"/>
+        <a:font script="Bugi" typeface="Leelawadee UI"/>
+        <a:font script="Bopo" typeface="Microsoft JhengHei"/>
+        <a:font script="Java" typeface="Javanese Text"/>
+        <a:font script="Lisu" typeface="Segoe UI"/>
+        <a:font script="Mymr" typeface="Myanmar Text"/>
+        <a:font script="Nkoo" typeface="Ebrima"/>
+        <a:font script="Olck" typeface="Nirmala UI"/>
+        <a:font script="Osma" typeface="Ebrima"/>
+        <a:font script="Phag" typeface="Phagspa"/>
+        <a:font script="Syrn" typeface="Estrangelo Edessa"/>
+        <a:font script="Syrj" typeface="Estrangelo Edessa"/>
+        <a:font script="Syre" typeface="Estrangelo Edessa"/>
+        <a:font script="Sora" typeface="Nirmala UI"/>
+        <a:font script="Tale" typeface="Microsoft Tai Le"/>
+        <a:font script="Talu" typeface="Microsoft New Tai Lue"/>
+        <a:font script="Tfng" typeface="Ebrima"/>
+      </a:majorFont>
+      <a:minorFont>
+        <a:latin typeface="Aptos" panose="02110004020202020204"/>
+        <a:ea typeface=""/>
+        <a:cs typeface=""/>
+        <a:font script="Jpan" typeface="游ゴシック"/>
+        <a:font script="Hang" typeface="맑은 고딕"/>
+        <a:font script="Hans" typeface="等线"/>
+        <a:font script="Hant" typeface="新細明體"/>
+        <a:font script="Arab" typeface="Arial"/>
+        <a:font script="Hebr" typeface="Arial"/>
+        <a:font script="Thai" typeface="Cordia New"/>
+        <a:font script="Ethi" typeface="Nyala"/>
+        <a:font script="Beng" typeface="Vrinda"/>
+        <a:font script="Gujr" typeface="Shruti"/>
+        <a:font script="Khmr" typeface="DaunPenh"/>
+        <a:font script="Knda" typeface="Tunga"/>
+        <a:font script="Guru" typeface="Raavi"/>
+        <a:font script="Cans" typeface="Euphemia"/>
+        <a:font script="Cher" typeface="Plantagenet Cherokee"/>
+        <a:font script="Yiii" typeface="Microsoft Yi Baiti"/>
+        <a:font script="Tibt" typeface="Microsoft Himalaya"/>
+        <a:font script="Thaa" typeface="MV Boli"/>
+        <a:font script="Deva" typeface="Mangal"/>
+        <a:font script="Telu" typeface="Gautami"/>
+        <a:font script="Taml" typeface="Latha"/>
+        <a:font script="Syrc" typeface="Estrangelo Edessa"/>
+        <a:font script="Orya" typeface="Kalinga"/>
+        <a:font script="Mlym" typeface="Kartika"/>
+        <a:font script="Laoo" typeface="DokChampa"/>
+        <a:font script="Sinh" typeface="Iskoola Pota"/>
+        <a:font script="Mong" typeface="Mongolian Baiti"/>
+        <a:font script="Viet" typeface="Arial"/>
+        <a:font script="Uigh" typeface="Microsoft Uighur"/>
+        <a:font script="Geor" typeface="Sylfaen"/>
+        <a:font script="Armn" typeface="Arial"/>
+        <a:font script="Bugi" typeface="Leelawadee UI"/>
+        <a:font script="Bopo" typeface="Microsoft JhengHei"/>
+        <a:font script="Java" typeface="Javanese Text"/>
+        <a:font script="Lisu" typeface="Segoe UI"/>
+        <a:font script="Mymr" typeface="Myanmar Text"/>
+        <a:font script="Nkoo" typeface="Ebrima"/>
+        <a:font script="Olck" typeface="Nirmala UI"/>
+        <a:font script="Osma" typeface="Ebrima"/>
+        <a:font script="Phag" typeface="Phagspa"/>
+        <a:font script="Syrn" typeface="Estrangelo Edessa"/>
+        <a:font script="Syrj" typeface="Estrangelo Edessa"/>
+        <a:font script="Syre" typeface="Estrangelo Edessa"/>
+        <a:font script="Sora" typeface="Nirmala UI"/>
+        <a:font script="Tale" typeface="Microsoft Tai Le"/>
+        <a:font script="Talu" typeface="Microsoft New Tai Lue"/>
+        <a:font script="Tfng" typeface="Ebrima"/>
+      </a:minorFont>
+    </a:fontScheme>
+    <a:fmtScheme name="Office">
+      <a:fillStyleLst>
+        <a:solidFill>
+          <a:schemeClr val="phClr"/>
+        </a:solidFill>
+        <a:gradFill rotWithShape="1">
+          <a:gsLst>
+            <a:gs pos="0">
+              <a:schemeClr val="phClr">
+                <a:lumMod val="110000"/>
+                <a:satMod val="105000"/>
+                <a:tint val="67000"/>
+              </a:schemeClr>
+            </a:gs>
+            <a:gs pos="50000">
+              <a:schemeClr val="phClr">
+                <a:lumMod val="105000"/>
+                <a:satMod val="103000"/>
+                <a:tint val="73000"/>
+              </a:schemeClr>
+            </a:gs>
+            <a:gs pos="100000">
+              <a:schemeClr val="phClr">
+                <a:lumMod val="105000"/>
+                <a:satMod val="109000"/>
+                <a:tint val="81000"/>
+              </a:schemeClr>
+            </a:gs>
+          </a:gsLst>
+          <a:lin ang="5400000" scaled="0"/>
+        </a:gradFill>
+        <a:gradFill rotWithShape="1">
+          <a:gsLst>
+            <a:gs pos="0">
+              <a:schemeClr val="phClr">
+                <a:satMod val="103000"/>
+                <a:lumMod val="102000"/>
+                <a:tint val="94000"/>
+              </a:schemeClr>
+            </a:gs>
+            <a:gs pos="50000">
+              <a:schemeClr val="phClr">
+                <a:satMod val="110000"/>
+                <a:lumMod val="100000"/>
+                <a:shade val="100000"/>
+              </a:schemeClr>
+            </a:gs>
+            <a:gs pos="100000">
+              <a:schemeClr val="phClr">
+                <a:lumMod val="99000"/>
+                <a:satMod val="120000"/>
+                <a:shade val="78000"/>
+              </a:schemeClr>
+            </a:gs>
+          </a:gsLst>
+          <a:lin ang="5400000" scaled="0"/>
+        </a:gradFill>
+      </a:fillStyleLst>
+      <a:lnStyleLst>
+        <a:ln w="12700" cap="flat" cmpd="sng" algn="ctr">
+          <a:solidFill>
+            <a:schemeClr val="phClr"/>
+          </a:solidFill>
+          <a:prstDash val="solid"/>
+          <a:miter lim="800000"/>
+        </a:ln>
+        <a:ln w="19050" cap="flat" cmpd="sng" algn="ctr">
+          <a:solidFill>
+            <a:schemeClr val="phClr"/>
+          </a:solidFill>
+          <a:prstDash val="solid"/>
+          <a:miter lim="800000"/>
+        </a:ln>
+        <a:ln w="25400" cap="flat" cmpd="sng" algn="ctr">
+          <a:solidFill>
+            <a:schemeClr val="phClr"/>
+          </a:solidFill>
+          <a:prstDash val="solid"/>
+          <a:miter lim="800000"/>
+        </a:ln>
+      </a:lnStyleLst>
+      <a:effectStyleLst>
+        <a:effectStyle>
+          <a:effectLst/>
+        </a:effectStyle>
+        <a:effectStyle>
+          <a:effectLst/>
+        </a:effectStyle>
+        <a:effectStyle>
+          <a:effectLst>
+            <a:outerShdw blurRad="57150" dist="19050" dir="5400000" algn="ctr" rotWithShape="0">
+              <a:srgbClr val="000000">
+                <a:alpha val="63000"/>
+              </a:srgbClr>
+            </a:outerShdw>
+          </a:effectLst>
+        </a:effectStyle>
+      </a:effectStyleLst>
+      <a:bgFillStyleLst>
+        <a:solidFill>
+          <a:schemeClr val="phClr"/>
+        </a:solidFill>
+        <a:solidFill>
+          <a:schemeClr val="phClr">
+            <a:tint val="95000"/>
+            <a:satMod val="170000"/>
+          </a:schemeClr>
+        </a:solidFill>
+        <a:gradFill rotWithShape="1">
+          <a:gsLst>
+            <a:gs pos="0">
+              <a:schemeClr val="phClr">
+                <a:tint val="93000"/>
+                <a:satMod val="150000"/>
+                <a:shade val="98000"/>
+                <a:lumMod val="102000"/>
+              </a:schemeClr>
+            </a:gs>
+            <a:gs pos="50000">
+              <a:schemeClr val="phClr">
+                <a:tint val="98000"/>
+                <a:satMod val="130000"/>
+                <a:shade val="90000"/>
+                <a:lumMod val="103000"/>
+              </a:schemeClr>
+            </a:gs>
+            <a:gs pos="100000">
+              <a:schemeClr val="phClr">
+                <a:shade val="63000"/>
+                <a:satMod val="120000"/>
+              </a:schemeClr>
+            </a:gs>
+          </a:gsLst>
+          <a:lin ang="5400000" scaled="0"/>
+        </a:gradFill>
+      </a:bgFillStyleLst>
+    </a:fmtScheme>
+  </a:themeElements>
+  <a:objectDefaults>
+    <a:lnDef>
+      <a:spPr/>
+      <a:bodyPr/>
+      <a:lstStyle/>
+      <a:style>
+        <a:lnRef idx="2">
+          <a:schemeClr val="accent1"/>
+        </a:lnRef>
+        <a:fillRef idx="0">
+          <a:schemeClr val="accent1"/>
+        </a:fillRef>
+        <a:effectRef idx="1">
+          <a:schemeClr val="accent1"/>
+        </a:effectRef>
+        <a:fontRef idx="minor">
+          <a:schemeClr val="tx1"/>
+        </a:fontRef>
+      </a:style>
+    </a:lnDef>
+  </a:objectDefaults>
+  <a:extraClrSchemeLst/>
+  <a:extLst>
+    <a:ext uri="{05A4C25C-085E-4340-85A3-A5531E510DB2}">
+      <thm15:themeFamily xmlns:thm15="http://schemas.microsoft.com/office/thememl/2012/main" name="Office Theme" id="{2E142A2C-CD16-42D6-873A-C26D2A0506FA}" vid="{1BDDFF52-6CD6-40A5-AB3C-68EB2F1E4D0A}"/>
+    </a:ext>
+  </a:extLst>
+</a:theme>
 </file>
</xml_diff>